<commit_message>
Standardize section number punctuation across dataset slides
</commit_message>
<xml_diff>
--- a/slides/datasets-in-10-minutes-coco.pptx
+++ b/slides/datasets-in-10-minutes-coco.pptx
@@ -7352,7 +7352,7 @@
                 <a:ea typeface="Noto Sans CJK JP"/>
                 <a:cs typeface="Noto Sans"/>
               </a:rPr>
-              <a:t>1 COCOの認識課題と領域注釈の実例</a:t>
+              <a:t>1. COCOの認識課題と領域注釈の実例</a:t>
             </a:r>
           </a:p>
         </p:txBody>
@@ -7586,7 +7586,7 @@
                 <a:ea typeface="Noto Sans CJK JP"/>
                 <a:cs typeface="Noto Sans"/>
               </a:rPr>
-              <a:t>1 COCOの認識課題と領域注釈の実例</a:t>
+              <a:t>1. COCOの認識課題と領域注釈の実例</a:t>
             </a:r>
           </a:p>
         </p:txBody>
@@ -7835,7 +7835,7 @@
                 <a:ea typeface="Noto Sans CJK JP"/>
                 <a:cs typeface="Noto Sans"/>
               </a:rPr>
-              <a:t>1 COCOの認識課題と領域注釈の実例</a:t>
+              <a:t>1. COCOの認識課題と領域注釈の実例</a:t>
             </a:r>
           </a:p>
         </p:txBody>
@@ -8409,7 +8409,7 @@
                 <a:ea typeface="Noto Sans CJK JP"/>
                 <a:cs typeface="Noto Sans"/>
               </a:rPr>
-              <a:t>1 COCOの認識課題と領域注釈の実例</a:t>
+              <a:t>1. COCOの認識課題と領域注釈の実例</a:t>
             </a:r>
           </a:p>
         </p:txBody>
@@ -8652,7 +8652,7 @@
                 <a:ea typeface="Noto Sans CJK JP"/>
                 <a:cs typeface="Noto Sans"/>
               </a:rPr>
-              <a:t>1 COCOの認識課題と領域注釈の実例</a:t>
+              <a:t>1. COCOの認識課題と領域注釈の実例</a:t>
             </a:r>
           </a:p>
         </p:txBody>
@@ -9226,7 +9226,7 @@
                 <a:ea typeface="Noto Sans CJK JP"/>
                 <a:cs typeface="Noto Sans"/>
               </a:rPr>
-              <a:t>1 COCOの認識課題と領域注釈の実例</a:t>
+              <a:t>1. COCOの認識課題と領域注釈の実例</a:t>
             </a:r>
           </a:p>
         </p:txBody>
@@ -9539,7 +9539,7 @@
                 <a:ea typeface="Noto Sans CJK JP"/>
                 <a:cs typeface="Noto Sans"/>
               </a:rPr>
-              <a:t>1 COCOの認識課題と領域注釈の実例</a:t>
+              <a:t>1. COCOの認識課題と領域注釈の実例</a:t>
             </a:r>
           </a:p>
         </p:txBody>
@@ -9734,7 +9734,7 @@
                 <a:ea typeface="Noto Sans CJK JP"/>
                 <a:cs typeface="Noto Sans"/>
               </a:rPr>
-              <a:t>2 画像の収集方法と物体注釈の構造</a:t>
+              <a:t>2. 画像の収集方法と物体注釈の構造</a:t>
             </a:r>
           </a:p>
         </p:txBody>
@@ -9788,7 +9788,7 @@
                 <a:ea typeface="Noto Sans CJK JP"/>
                 <a:cs typeface="Noto Sans"/>
               </a:rPr>
-              <a:t>2 画像の収集方法と物体注釈の構造</a:t>
+              <a:t>2. 画像の収集方法と物体注釈の構造</a:t>
             </a:r>
           </a:p>
         </p:txBody>
@@ -10040,7 +10040,7 @@
                 <a:ea typeface="Noto Sans CJK JP"/>
                 <a:cs typeface="Noto Sans"/>
               </a:rPr>
-              <a:t>2 画像の収集方法と物体注釈の構造</a:t>
+              <a:t>2. 画像の収集方法と物体注釈の構造</a:t>
             </a:r>
           </a:p>
         </p:txBody>
@@ -10409,7 +10409,7 @@
                 <a:ea typeface="Noto Sans CJK JP"/>
                 <a:cs typeface="Noto Sans"/>
               </a:rPr>
-              <a:t>2 画像の収集方法と物体注釈の構造</a:t>
+              <a:t>2. 画像の収集方法と物体注釈の構造</a:t>
             </a:r>
           </a:p>
         </p:txBody>
@@ -10937,7 +10937,7 @@
                 <a:ea typeface="Noto Sans CJK JP"/>
                 <a:cs typeface="Noto Sans"/>
               </a:rPr>
-              <a:t>2 画像の収集方法と物体注釈の構造</a:t>
+              <a:t>2. 画像の収集方法と物体注釈の構造</a:t>
             </a:r>
           </a:p>
         </p:txBody>
@@ -12097,7 +12097,7 @@
                 <a:ea typeface="Noto Sans CJK JP"/>
                 <a:cs typeface="Noto Sans"/>
               </a:rPr>
-              <a:t>2 画像の収集方法と物体注釈の構造</a:t>
+              <a:t>2. 画像の収集方法と物体注釈の構造</a:t>
             </a:r>
           </a:p>
         </p:txBody>
@@ -12466,7 +12466,7 @@
                 <a:ea typeface="Noto Sans CJK JP"/>
                 <a:cs typeface="Noto Sans"/>
               </a:rPr>
-              <a:t>2 画像の収集方法と物体注釈の構造</a:t>
+              <a:t>2. 画像の収集方法と物体注釈の構造</a:t>
             </a:r>
           </a:p>
         </p:txBody>
@@ -12905,7 +12905,7 @@
                 <a:ea typeface="Noto Sans CJK JP"/>
                 <a:cs typeface="Noto Sans"/>
               </a:rPr>
-              <a:t>2 画像の収集方法と物体注釈の構造</a:t>
+              <a:t>2. 画像の収集方法と物体注釈の構造</a:t>
             </a:r>
           </a:p>
         </p:txBody>
@@ -13274,7 +13274,7 @@
                 <a:ea typeface="Noto Sans CJK JP"/>
                 <a:cs typeface="Noto Sans"/>
               </a:rPr>
-              <a:t>2 画像の収集方法と物体注釈の構造</a:t>
+              <a:t>2. 画像の収集方法と物体注釈の構造</a:t>
             </a:r>
           </a:p>
         </p:txBody>
@@ -13593,7 +13593,7 @@
                 <a:ea typeface="Noto Sans CJK JP"/>
                 <a:cs typeface="Noto Sans"/>
               </a:rPr>
-              <a:t>2 画像の収集方法と物体注釈の構造</a:t>
+              <a:t>2. 画像の収集方法と物体注釈の構造</a:t>
             </a:r>
           </a:p>
         </p:txBody>
@@ -13912,7 +13912,7 @@
                 <a:ea typeface="Noto Sans CJK JP"/>
                 <a:cs typeface="Noto Sans"/>
               </a:rPr>
-              <a:t>2 画像の収集方法と物体注釈の構造</a:t>
+              <a:t>2. 画像の収集方法と物体注釈の構造</a:t>
             </a:r>
           </a:p>
         </p:txBody>
@@ -14149,7 +14149,7 @@
                 <a:ea typeface="Noto Sans CJK JP"/>
                 <a:cs typeface="Noto Sans"/>
               </a:rPr>
-              <a:t>2 画像の収集方法と物体注釈の構造</a:t>
+              <a:t>2. 画像の収集方法と物体注釈の構造</a:t>
             </a:r>
           </a:p>
         </p:txBody>
@@ -16647,7 +16647,7 @@
                 <a:ea typeface="Noto Sans CJK JP"/>
                 <a:cs typeface="Noto Sans"/>
               </a:rPr>
-              <a:t>2 画像の収集方法と物体注釈の構造</a:t>
+              <a:t>2. 画像の収集方法と物体注釈の構造</a:t>
             </a:r>
           </a:p>
         </p:txBody>
@@ -19278,7 +19278,7 @@
                 <a:ea typeface="Noto Sans CJK JP"/>
                 <a:cs typeface="Noto Sans"/>
               </a:rPr>
-              <a:t>2 画像の収集方法と物体注釈の構造</a:t>
+              <a:t>2. 画像の収集方法と物体注釈の構造</a:t>
             </a:r>
           </a:p>
         </p:txBody>
@@ -19770,7 +19770,7 @@
                 <a:ea typeface="Noto Sans CJK JP"/>
                 <a:cs typeface="Noto Sans"/>
               </a:rPr>
-              <a:t>1 COCOの認識課題と領域注釈の実例</a:t>
+              <a:t>1. COCOの認識課題と領域注釈の実例</a:t>
             </a:r>
           </a:p>
         </p:txBody>
@@ -19824,7 +19824,7 @@
                 <a:ea typeface="Noto Sans CJK JP"/>
                 <a:cs typeface="Noto Sans"/>
               </a:rPr>
-              <a:t>1 COCOの認識課題と領域注釈の実例</a:t>
+              <a:t>1. COCOの認識課題と領域注釈の実例</a:t>
             </a:r>
           </a:p>
         </p:txBody>
@@ -19950,7 +19950,7 @@
                 <a:ea typeface="Noto Sans CJK JP"/>
                 <a:cs typeface="Noto Sans"/>
               </a:rPr>
-              <a:t>2 画像の収集方法と物体注釈の構造</a:t>
+              <a:t>2. 画像の収集方法と物体注釈の構造</a:t>
             </a:r>
           </a:p>
         </p:txBody>
@@ -21066,7 +21066,7 @@
                 <a:ea typeface="Noto Sans CJK JP"/>
                 <a:cs typeface="Noto Sans"/>
               </a:rPr>
-              <a:t>2 画像の収集方法と物体注釈の構造</a:t>
+              <a:t>2. 画像の収集方法と物体注釈の構造</a:t>
             </a:r>
           </a:p>
         </p:txBody>
@@ -21408,7 +21408,7 @@
                 <a:ea typeface="Noto Sans CJK JP"/>
                 <a:cs typeface="Noto Sans"/>
               </a:rPr>
-              <a:t>2 画像の収集方法と物体注釈の構造</a:t>
+              <a:t>2. 画像の収集方法と物体注釈の構造</a:t>
             </a:r>
           </a:p>
         </p:txBody>
@@ -21647,7 +21647,7 @@
                 <a:ea typeface="Noto Sans CJK JP"/>
                 <a:cs typeface="Noto Sans"/>
               </a:rPr>
-              <a:t>2 画像の収集方法と物体注釈の構造</a:t>
+              <a:t>2. 画像の収集方法と物体注釈の構造</a:t>
             </a:r>
           </a:p>
         </p:txBody>
@@ -23095,7 +23095,7 @@
                 <a:ea typeface="Noto Sans CJK JP"/>
                 <a:cs typeface="Noto Sans"/>
               </a:rPr>
-              <a:t>2 画像の収集方法と物体注釈の構造</a:t>
+              <a:t>2. 画像の収集方法と物体注釈の構造</a:t>
             </a:r>
           </a:p>
         </p:txBody>
@@ -23269,7 +23269,7 @@
                 <a:ea typeface="Noto Sans CJK JP"/>
                 <a:cs typeface="Noto Sans"/>
               </a:rPr>
-              <a:t>3 物体検出・領域分割の評価とモデル性能</a:t>
+              <a:t>3. 物体検出・領域分割の評価とモデル性能</a:t>
             </a:r>
           </a:p>
         </p:txBody>
@@ -23323,7 +23323,7 @@
                 <a:ea typeface="Noto Sans CJK JP"/>
                 <a:cs typeface="Noto Sans"/>
               </a:rPr>
-              <a:t>3 物体検出・領域分割の評価とモデル性能</a:t>
+              <a:t>3. 物体検出・領域分割の評価とモデル性能</a:t>
             </a:r>
           </a:p>
         </p:txBody>
@@ -23449,7 +23449,7 @@
                 <a:ea typeface="Noto Sans CJK JP"/>
                 <a:cs typeface="Noto Sans"/>
               </a:rPr>
-              <a:t>3 物体検出・領域分割の評価とモデル性能</a:t>
+              <a:t>3. 物体検出・領域分割の評価とモデル性能</a:t>
             </a:r>
           </a:p>
         </p:txBody>
@@ -24155,7 +24155,7 @@
                 <a:ea typeface="Noto Sans CJK JP"/>
                 <a:cs typeface="Noto Sans"/>
               </a:rPr>
-              <a:t>3 物体検出・領域分割の評価とモデル性能</a:t>
+              <a:t>3. 物体検出・領域分割の評価とモデル性能</a:t>
             </a:r>
           </a:p>
         </p:txBody>
@@ -24348,7 +24348,7 @@
                 <a:ea typeface="Noto Sans CJK JP"/>
                 <a:cs typeface="Noto Sans"/>
               </a:rPr>
-              <a:t>3 物体検出・領域分割の評価とモデル性能</a:t>
+              <a:t>3. 物体検出・領域分割の評価とモデル性能</a:t>
             </a:r>
           </a:p>
         </p:txBody>
@@ -25326,7 +25326,7 @@
                 <a:ea typeface="Noto Sans CJK JP"/>
                 <a:cs typeface="Noto Sans"/>
               </a:rPr>
-              <a:t>3 物体検出・領域分割の評価とモデル性能</a:t>
+              <a:t>3. 物体検出・領域分割の評価とモデル性能</a:t>
             </a:r>
           </a:p>
         </p:txBody>
@@ -25519,7 +25519,7 @@
                 <a:ea typeface="Noto Sans CJK JP"/>
                 <a:cs typeface="Noto Sans"/>
               </a:rPr>
-              <a:t>1 COCOの認識課題と領域注釈の実例</a:t>
+              <a:t>1. COCOの認識課題と領域注釈の実例</a:t>
             </a:r>
           </a:p>
         </p:txBody>
@@ -25851,7 +25851,7 @@
                 <a:ea typeface="Noto Sans CJK JP"/>
                 <a:cs typeface="Noto Sans"/>
               </a:rPr>
-              <a:t>3 物体検出・領域分割の評価とモデル性能</a:t>
+              <a:t>3. 物体検出・領域分割の評価とモデル性能</a:t>
             </a:r>
           </a:p>
         </p:txBody>
@@ -26170,7 +26170,7 @@
                 <a:ea typeface="Noto Sans CJK JP"/>
                 <a:cs typeface="Noto Sans"/>
               </a:rPr>
-              <a:t>3 物体検出・領域分割の評価とモデル性能</a:t>
+              <a:t>3. 物体検出・領域分割の評価とモデル性能</a:t>
             </a:r>
           </a:p>
         </p:txBody>
@@ -26489,7 +26489,7 @@
                 <a:ea typeface="Noto Sans CJK JP"/>
                 <a:cs typeface="Noto Sans"/>
               </a:rPr>
-              <a:t>3 物体検出・領域分割の評価とモデル性能</a:t>
+              <a:t>3. 物体検出・領域分割の評価とモデル性能</a:t>
             </a:r>
           </a:p>
         </p:txBody>
@@ -27092,7 +27092,7 @@
                 <a:ea typeface="Noto Sans CJK JP"/>
                 <a:cs typeface="Noto Sans"/>
               </a:rPr>
-              <a:t>3 物体検出・領域分割の評価とモデル性能</a:t>
+              <a:t>3. 物体検出・領域分割の評価とモデル性能</a:t>
             </a:r>
           </a:p>
         </p:txBody>
@@ -27522,7 +27522,7 @@
                 <a:ea typeface="Noto Sans CJK JP"/>
                 <a:cs typeface="Noto Sans"/>
               </a:rPr>
-              <a:t>3 物体検出・領域分割の評価とモデル性能</a:t>
+              <a:t>3. 物体検出・領域分割の評価とモデル性能</a:t>
             </a:r>
           </a:p>
         </p:txBody>
@@ -28919,7 +28919,7 @@
                 <a:ea typeface="Noto Sans CJK JP"/>
                 <a:cs typeface="Noto Sans"/>
               </a:rPr>
-              <a:t>3 物体検出・領域分割の評価とモデル性能</a:t>
+              <a:t>3. 物体検出・領域分割の評価とモデル性能</a:t>
             </a:r>
           </a:p>
         </p:txBody>
@@ -29238,7 +29238,7 @@
                 <a:ea typeface="Noto Sans CJK JP"/>
                 <a:cs typeface="Noto Sans"/>
               </a:rPr>
-              <a:t>3 物体検出・領域分割の評価とモデル性能</a:t>
+              <a:t>3. 物体検出・領域分割の評価とモデル性能</a:t>
             </a:r>
           </a:p>
         </p:txBody>
@@ -29568,7 +29568,7 @@
                 <a:ea typeface="Noto Sans CJK JP"/>
                 <a:cs typeface="Noto Sans"/>
               </a:rPr>
-              <a:t>3 物体検出・領域分割の評価とモデル性能</a:t>
+              <a:t>3. 物体検出・領域分割の評価とモデル性能</a:t>
             </a:r>
           </a:p>
         </p:txBody>
@@ -29757,7 +29757,7 @@
                 <a:ea typeface="Noto Sans CJK JP"/>
                 <a:cs typeface="Noto Sans"/>
               </a:rPr>
-              <a:t>4 COCOの利用動向と画像・注釈の入手方法</a:t>
+              <a:t>4. COCOの利用動向と画像・注釈の入手方法</a:t>
             </a:r>
           </a:p>
         </p:txBody>
@@ -29811,7 +29811,7 @@
                 <a:ea typeface="Noto Sans CJK JP"/>
                 <a:cs typeface="Noto Sans"/>
               </a:rPr>
-              <a:t>4 COCOの利用動向と画像・注釈の入手方法</a:t>
+              <a:t>4. COCOの利用動向と画像・注釈の入手方法</a:t>
             </a:r>
           </a:p>
         </p:txBody>
@@ -30063,7 +30063,7 @@
                 <a:ea typeface="Noto Sans CJK JP"/>
                 <a:cs typeface="Noto Sans"/>
               </a:rPr>
-              <a:t>4 COCOの利用動向と画像・注釈の入手方法</a:t>
+              <a:t>4. COCOの利用動向と画像・注釈の入手方法</a:t>
             </a:r>
           </a:p>
         </p:txBody>
@@ -30426,7 +30426,7 @@
                 <a:ea typeface="Noto Sans CJK JP"/>
                 <a:cs typeface="Noto Sans"/>
               </a:rPr>
-              <a:t>1 COCOの認識課題と領域注釈の実例</a:t>
+              <a:t>1. COCOの認識課題と領域注釈の実例</a:t>
             </a:r>
           </a:p>
         </p:txBody>
@@ -30745,7 +30745,7 @@
                 <a:ea typeface="Noto Sans CJK JP"/>
                 <a:cs typeface="Noto Sans"/>
               </a:rPr>
-              <a:t>4 COCOの利用動向と画像・注釈の入手方法</a:t>
+              <a:t>4. COCOの利用動向と画像・注釈の入手方法</a:t>
             </a:r>
           </a:p>
         </p:txBody>
@@ -31058,7 +31058,7 @@
                 <a:ea typeface="Noto Sans CJK JP"/>
                 <a:cs typeface="Noto Sans"/>
               </a:rPr>
-              <a:t>4 COCOの利用動向と画像・注釈の入手方法</a:t>
+              <a:t>4. COCOの利用動向と画像・注釈の入手方法</a:t>
             </a:r>
           </a:p>
         </p:txBody>
@@ -31925,7 +31925,7 @@
                 <a:ea typeface="Noto Sans CJK JP"/>
                 <a:cs typeface="Noto Sans"/>
               </a:rPr>
-              <a:t>4 COCOの利用動向と画像・注釈の入手方法</a:t>
+              <a:t>4. COCOの利用動向と画像・注釈の入手方法</a:t>
             </a:r>
           </a:p>
         </p:txBody>
@@ -32553,7 +32553,7 @@
                 <a:ea typeface="Noto Sans CJK JP"/>
                 <a:cs typeface="Noto Sans"/>
               </a:rPr>
-              <a:t>4 COCOの利用動向と画像・注釈の入手方法</a:t>
+              <a:t>4. COCOの利用動向と画像・注釈の入手方法</a:t>
             </a:r>
           </a:p>
         </p:txBody>
@@ -32872,7 +32872,7 @@
                 <a:ea typeface="Noto Sans CJK JP"/>
                 <a:cs typeface="Noto Sans"/>
               </a:rPr>
-              <a:t>4 COCOの利用動向と画像・注釈の入手方法</a:t>
+              <a:t>4. COCOの利用動向と画像・注釈の入手方法</a:t>
             </a:r>
           </a:p>
         </p:txBody>
@@ -33566,7 +33566,7 @@
                 <a:ea typeface="Noto Sans CJK JP"/>
                 <a:cs typeface="Noto Sans"/>
               </a:rPr>
-              <a:t>Appendix 1 開発者の研究と領域認識の評価仕様</a:t>
+              <a:t>Appendix 1. 開発者の研究と領域認識の評価仕様</a:t>
             </a:r>
           </a:p>
         </p:txBody>
@@ -33867,7 +33867,7 @@
                 <a:ea typeface="Noto Sans CJK JP"/>
                 <a:cs typeface="Noto Sans"/>
               </a:rPr>
-              <a:t>Appendix 1 開発者の研究と領域認識の評価仕様</a:t>
+              <a:t>Appendix 1. 開発者の研究と領域認識の評価仕様</a:t>
             </a:r>
           </a:p>
         </p:txBody>
@@ -35197,7 +35197,7 @@
                 <a:ea typeface="Noto Sans CJK JP"/>
                 <a:cs typeface="Noto Sans"/>
               </a:rPr>
-              <a:t>Appendix 1 開発者の研究と領域認識の評価仕様</a:t>
+              <a:t>Appendix 1. 開発者の研究と領域認識の評価仕様</a:t>
             </a:r>
           </a:p>
         </p:txBody>
@@ -35408,7 +35408,7 @@
                 <a:ea typeface="Noto Sans CJK JP"/>
                 <a:cs typeface="Noto Sans"/>
               </a:rPr>
-              <a:t>1 COCOの認識課題と領域注釈の実例</a:t>
+              <a:t>1. COCOの認識課題と領域注釈の実例</a:t>
             </a:r>
           </a:p>
         </p:txBody>
@@ -36381,7 +36381,7 @@
                 <a:ea typeface="Noto Sans CJK JP"/>
                 <a:cs typeface="Noto Sans"/>
               </a:rPr>
-              <a:t>Appendix 1 開発者の研究と領域認識の評価仕様</a:t>
+              <a:t>Appendix 1. 開発者の研究と領域認識の評価仕様</a:t>
             </a:r>
           </a:p>
         </p:txBody>
@@ -36678,7 +36678,7 @@
                 <a:ea typeface="Noto Sans CJK JP"/>
                 <a:cs typeface="Noto Sans"/>
               </a:rPr>
-              <a:t>Appendix 2 128画像の部分集合における注釈数の分布</a:t>
+              <a:t>Appendix 2. 128画像の部分集合における注釈数の分布</a:t>
             </a:r>
           </a:p>
         </p:txBody>
@@ -36871,7 +36871,7 @@
                 <a:ea typeface="Noto Sans CJK JP"/>
                 <a:cs typeface="Noto Sans"/>
               </a:rPr>
-              <a:t>Appendix 2 128画像の部分集合における注釈数の分布</a:t>
+              <a:t>Appendix 2. 128画像の部分集合における注釈数の分布</a:t>
             </a:r>
           </a:p>
         </p:txBody>
@@ -37120,7 +37120,7 @@
                 <a:ea typeface="Noto Sans CJK JP"/>
                 <a:cs typeface="Noto Sans"/>
               </a:rPr>
-              <a:t>Appendix 2 128画像の部分集合における注釈数の分布</a:t>
+              <a:t>Appendix 2. 128画像の部分集合における注釈数の分布</a:t>
             </a:r>
           </a:p>
         </p:txBody>
@@ -37987,7 +37987,7 @@
                 <a:ea typeface="Noto Sans CJK JP"/>
                 <a:cs typeface="Noto Sans"/>
               </a:rPr>
-              <a:t>Appendix 2 128画像の部分集合における注釈数の分布</a:t>
+              <a:t>Appendix 2. 128画像の部分集合における注釈数の分布</a:t>
             </a:r>
           </a:p>
         </p:txBody>
@@ -38236,7 +38236,7 @@
                 <a:ea typeface="Noto Sans CJK JP"/>
                 <a:cs typeface="Noto Sans"/>
               </a:rPr>
-              <a:t>Appendix 2 128画像の部分集合における注釈数の分布</a:t>
+              <a:t>Appendix 2. 128画像の部分集合における注釈数の分布</a:t>
             </a:r>
           </a:p>
         </p:txBody>
@@ -38485,7 +38485,7 @@
                 <a:ea typeface="Noto Sans CJK JP"/>
                 <a:cs typeface="Noto Sans"/>
               </a:rPr>
-              <a:t>Appendix 3 画像と物体領域の追加例</a:t>
+              <a:t>Appendix 3. 画像と物体領域の追加例</a:t>
             </a:r>
           </a:p>
         </p:txBody>
@@ -38734,7 +38734,7 @@
                 <a:ea typeface="Noto Sans CJK JP"/>
                 <a:cs typeface="Noto Sans"/>
               </a:rPr>
-              <a:t>Appendix 3 画像と物体領域の追加例</a:t>
+              <a:t>Appendix 3. 画像と物体領域の追加例</a:t>
             </a:r>
           </a:p>
         </p:txBody>
@@ -38983,7 +38983,7 @@
                 <a:ea typeface="Noto Sans CJK JP"/>
                 <a:cs typeface="Noto Sans"/>
               </a:rPr>
-              <a:t>Appendix 3 画像と物体領域の追加例</a:t>
+              <a:t>Appendix 3. 画像と物体領域の追加例</a:t>
             </a:r>
           </a:p>
         </p:txBody>
@@ -39389,7 +39389,7 @@
                 <a:ea typeface="Noto Sans CJK JP"/>
                 <a:cs typeface="Noto Sans"/>
               </a:rPr>
-              <a:t>Appendix 3 画像と物体領域の追加例</a:t>
+              <a:t>Appendix 3. 画像と物体領域の追加例</a:t>
             </a:r>
           </a:p>
         </p:txBody>
@@ -39764,7 +39764,7 @@
                 <a:ea typeface="Noto Sans CJK JP"/>
                 <a:cs typeface="Noto Sans"/>
               </a:rPr>
-              <a:t>1 COCOの認識課題と領域注釈の実例</a:t>
+              <a:t>1. COCOの認識課題と領域注釈の実例</a:t>
             </a:r>
           </a:p>
         </p:txBody>
@@ -39957,7 +39957,7 @@
                 <a:ea typeface="Noto Sans CJK JP"/>
                 <a:cs typeface="Noto Sans"/>
               </a:rPr>
-              <a:t>Appendix 3 画像と物体領域の追加例</a:t>
+              <a:t>Appendix 3. 画像と物体領域の追加例</a:t>
             </a:r>
           </a:p>
         </p:txBody>
@@ -40206,7 +40206,7 @@
                 <a:ea typeface="Noto Sans CJK JP"/>
                 <a:cs typeface="Noto Sans"/>
               </a:rPr>
-              <a:t>Appendix 3 画像と物体領域の追加例</a:t>
+              <a:t>Appendix 3. 画像と物体領域の追加例</a:t>
             </a:r>
           </a:p>
         </p:txBody>
@@ -40455,7 +40455,7 @@
                 <a:ea typeface="Noto Sans CJK JP"/>
                 <a:cs typeface="Noto Sans"/>
               </a:rPr>
-              <a:t>Appendix 3 画像と物体領域の追加例</a:t>
+              <a:t>Appendix 3. 画像と物体領域の追加例</a:t>
             </a:r>
           </a:p>
         </p:txBody>
@@ -40704,7 +40704,7 @@
                 <a:ea typeface="Noto Sans CJK JP"/>
                 <a:cs typeface="Noto Sans"/>
               </a:rPr>
-              <a:t>Appendix 3 画像と物体領域の追加例</a:t>
+              <a:t>Appendix 3. 画像と物体領域の追加例</a:t>
             </a:r>
           </a:p>
         </p:txBody>
@@ -40953,7 +40953,7 @@
                 <a:ea typeface="Noto Sans CJK JP"/>
                 <a:cs typeface="Noto Sans"/>
               </a:rPr>
-              <a:t>Appendix 3 画像と物体領域の追加例</a:t>
+              <a:t>Appendix 3. 画像と物体領域の追加例</a:t>
             </a:r>
           </a:p>
         </p:txBody>
@@ -41202,7 +41202,7 @@
                 <a:ea typeface="Noto Sans CJK JP"/>
                 <a:cs typeface="Noto Sans"/>
               </a:rPr>
-              <a:t>Appendix 3 画像と物体領域の追加例</a:t>
+              <a:t>Appendix 3. 画像と物体領域の追加例</a:t>
             </a:r>
           </a:p>
         </p:txBody>
@@ -41577,7 +41577,7 @@
                 <a:ea typeface="Noto Sans CJK JP"/>
                 <a:cs typeface="Noto Sans"/>
               </a:rPr>
-              <a:t>Appendix 4 全80物体カテゴリと画像・注釈の利用条件</a:t>
+              <a:t>Appendix 4. 全80物体カテゴリと画像・注釈の利用条件</a:t>
             </a:r>
           </a:p>
         </p:txBody>
@@ -41907,7 +41907,7 @@
                 <a:ea typeface="Noto Sans CJK JP"/>
                 <a:cs typeface="Noto Sans"/>
               </a:rPr>
-              <a:t>Appendix 4 全80物体カテゴリと画像・注釈の利用条件</a:t>
+              <a:t>Appendix 4. 全80物体カテゴリと画像・注釈の利用条件</a:t>
             </a:r>
           </a:p>
         </p:txBody>
@@ -42237,7 +42237,7 @@
                 <a:ea typeface="Noto Sans CJK JP"/>
                 <a:cs typeface="Noto Sans"/>
               </a:rPr>
-              <a:t>Appendix 4 全80物体カテゴリと画像・注釈の利用条件</a:t>
+              <a:t>Appendix 4. 全80物体カテゴリと画像・注釈の利用条件</a:t>
             </a:r>
           </a:p>
         </p:txBody>
@@ -42567,7 +42567,7 @@
                 <a:ea typeface="Noto Sans CJK JP"/>
                 <a:cs typeface="Noto Sans"/>
               </a:rPr>
-              <a:t>Appendix 4 全80物体カテゴリと画像・注釈の利用条件</a:t>
+              <a:t>Appendix 4. 全80物体カテゴリと画像・注釈の利用条件</a:t>
             </a:r>
           </a:p>
         </p:txBody>
@@ -42897,7 +42897,7 @@
                 <a:ea typeface="Noto Sans CJK JP"/>
                 <a:cs typeface="Noto Sans"/>
               </a:rPr>
-              <a:t>1 COCOの認識課題と領域注釈の実例</a:t>
+              <a:t>1. COCOの認識課題と領域注釈の実例</a:t>
             </a:r>
           </a:p>
         </p:txBody>
@@ -43216,7 +43216,7 @@
                 <a:ea typeface="Noto Sans CJK JP"/>
                 <a:cs typeface="Noto Sans"/>
               </a:rPr>
-              <a:t>Appendix 4 全80物体カテゴリと画像・注釈の利用条件</a:t>
+              <a:t>Appendix 4. 全80物体カテゴリと画像・注釈の利用条件</a:t>
             </a:r>
           </a:p>
         </p:txBody>
@@ -43442,7 +43442,7 @@
                 <a:ea typeface="Noto Sans CJK JP"/>
                 <a:cs typeface="Noto Sans"/>
               </a:rPr>
-              <a:t>Appendix 5 物体検出・領域分割の関連文献</a:t>
+              <a:t>Appendix 5. 物体検出・領域分割の関連文献</a:t>
             </a:r>
           </a:p>
         </p:txBody>
@@ -43989,7 +43989,7 @@
                 <a:ea typeface="Noto Sans CJK JP"/>
                 <a:cs typeface="Noto Sans"/>
               </a:rPr>
-              <a:t>Appendix 5 物体検出・領域分割の関連文献</a:t>
+              <a:t>Appendix 5. 物体検出・領域分割の関連文献</a:t>
             </a:r>
           </a:p>
         </p:txBody>
@@ -44536,7 +44536,7 @@
                 <a:ea typeface="Noto Sans CJK JP"/>
                 <a:cs typeface="Noto Sans"/>
               </a:rPr>
-              <a:t>Appendix 5 物体検出・領域分割の関連文献</a:t>
+              <a:t>Appendix 5. 物体検出・領域分割の関連文献</a:t>
             </a:r>
           </a:p>
         </p:txBody>
@@ -45083,7 +45083,7 @@
                 <a:ea typeface="Noto Sans CJK JP"/>
                 <a:cs typeface="Noto Sans"/>
               </a:rPr>
-              <a:t>1 COCOの認識課題と領域注釈の実例</a:t>
+              <a:t>1. COCOの認識課題と領域注釈の実例</a:t>
             </a:r>
           </a:p>
         </p:txBody>

</xml_diff>

<commit_message>
Center slide contents and present benchmark results before model details
</commit_message>
<xml_diff>
--- a/slides/datasets-in-10-minutes-coco.pptx
+++ b/slides/datasets-in-10-minutes-coco.pptx
@@ -46,9 +46,9 @@
     <p:sldId id="274" r:id="rId24"/>
     <p:sldId id="335" r:id="rId82"/>
     <p:sldId id="275" r:id="rId25"/>
+    <p:sldId id="276" r:id="rId26"/>
     <p:sldId id="336" r:id="rId83"/>
     <p:sldId id="337" r:id="rId84"/>
-    <p:sldId id="276" r:id="rId26"/>
     <p:sldId id="277" r:id="rId27"/>
     <p:sldId id="289" r:id="rId39"/>
     <p:sldId id="338" r:id="rId85"/>
@@ -10661,7 +10661,7 @@
         </p:nvSpPr>
         <p:spPr>
           <a:xfrm>
-            <a:off x="594360" y="1234440"/>
+            <a:off x="594360" y="1766163"/>
             <a:ext cx="7955279" cy="3749039"/>
           </a:xfrm>
           <a:prstGeom prst="rect">
@@ -27578,7 +27578,7 @@
                 <a:ea typeface="Noto Sans CJK JP"/>
                 <a:cs typeface="Noto Sans"/>
               </a:rPr>
-              <a:t>Faster R-CNNにはFPNを組み合わせた。</a:t>
+              <a:t>R50は50層の画像特徴モデル、FPNは多解像度の特徴統合、3xは学習期間の設定を表す。</a:t>
             </a:r>
           </a:p>
         </p:txBody>
@@ -33081,7 +33081,7 @@
         </p:nvSpPr>
         <p:spPr>
           <a:xfrm>
-            <a:off x="594360" y="960120"/>
+            <a:off x="594360" y="1001897"/>
             <a:ext cx="8138160" cy="3749039"/>
           </a:xfrm>
         </p:spPr>

</xml_diff>

<commit_message>
Remove redundant caveats throughout seven existing dataset decks
</commit_message>
<xml_diff>
--- a/slides/datasets-in-10-minutes-coco.pptx
+++ b/slides/datasets-in-10-minutes-coco.pptx
@@ -51,7 +51,6 @@
     <p:sldId id="337" r:id="rId84"/>
     <p:sldId id="277" r:id="rId27"/>
     <p:sldId id="289" r:id="rId39"/>
-    <p:sldId id="338" r:id="rId85"/>
     <p:sldId id="278" r:id="rId28"/>
     <p:sldId id="279" r:id="rId29"/>
     <p:sldId id="280" r:id="rId30"/>
@@ -10448,7 +10447,7 @@
                 <a:ea typeface="Noto Sans CJK JP"/>
                 <a:cs typeface="Noto Sans"/>
               </a:rPr>
-              <a:t>COCOの80物体カテゴリはVOCの4倍だが、画像数・注釈方法・評価指標も異なるため、得点を直接比較できない。</a:t>
+              <a:t>COCOの80物体カテゴリは、VOCの20カテゴリの4倍に当たる。</a:t>
             </a:r>
           </a:p>
         </p:txBody>
@@ -11908,39 +11907,7 @@
             <a:spAutoFit/>
           </a:bodyPr>
           <a:lstStyle/>
-          <a:p>
-            <a:pPr>
-              <a:lnSpc>
-                <a:spcPct val="110000"/>
-              </a:lnSpc>
-              <a:spcBef>
-                <a:spcPts val="0"/>
-              </a:spcBef>
-              <a:spcAft>
-                <a:spcPts val="0"/>
-              </a:spcAft>
-              <a:buNone/>
-              <a:defRPr sz="2000" b="0" lang="ja-JP">
-                <a:solidFill>
-                  <a:srgbClr val="303437"/>
-                </a:solidFill>
-                <a:latin typeface="Noto Sans"/>
-                <a:ea typeface="Noto Sans CJK JP"/>
-                <a:cs typeface="Noto Sans"/>
-              </a:defRPr>
-            </a:pPr>
-            <a:r>
-              <a:rPr sz="2000" b="0" lang="ja-JP">
-                <a:solidFill>
-                  <a:srgbClr val="303437"/>
-                </a:solidFill>
-                <a:latin typeface="Noto Sans"/>
-                <a:ea typeface="Noto Sans CJK JP"/>
-                <a:cs typeface="Noto Sans"/>
-              </a:rPr>
-              <a:t>この比較はタスクの整理であり、同じ評価集合の性能比較ではない。</a:t>
-            </a:r>
-          </a:p>
+          <a:p/>
         </p:txBody>
       </p:sp>
     </p:spTree>
@@ -13632,7 +13599,7 @@
                 <a:ea typeface="Noto Sans CJK JP"/>
                 <a:cs typeface="Noto Sans"/>
               </a:rPr>
-              <a:t>幅100・高さ60の矩形面積6,000画素と、物体の領域面積areaは一致するとは限らない。</a:t>
+              <a:t>areaは物体の領域マスクの面積を表す。</a:t>
             </a:r>
           </a:p>
         </p:txBody>
@@ -14341,7 +14308,7 @@
                 <a:ea typeface="Noto Sans CJK JP"/>
                 <a:cs typeface="Noto Sans"/>
               </a:rPr>
-              <a:t>4行×5列の符号化説明例。COCO画像からの集計ではない。</a:t>
+              <a:t>4行×5列の符号化説明例。</a:t>
             </a:r>
           </a:p>
         </p:txBody>
@@ -16839,7 +16806,7 @@
                 <a:ea typeface="Noto Sans CJK JP"/>
                 <a:cs typeface="Noto Sans"/>
               </a:rPr>
-              <a:t>4行×5列の符号化説明例。COCO画像からの集計ではない。</a:t>
+              <a:t>4行×5列の符号化説明例。</a:t>
             </a:r>
           </a:p>
         </p:txBody>
@@ -19759,39 +19726,6 @@
                 <a:cs typeface="Noto Sans"/>
               </a:rPr>
               <a:t>配布用の圧縮RLEでは連続長を文字列に符号化する。</a:t>
-            </a:r>
-          </a:p>
-          <a:p>
-            <a:pPr>
-              <a:lnSpc>
-                <a:spcPct val="110000"/>
-              </a:lnSpc>
-              <a:spcBef>
-                <a:spcPts val="0"/>
-              </a:spcBef>
-              <a:spcAft>
-                <a:spcPts val="0"/>
-              </a:spcAft>
-              <a:buNone/>
-              <a:defRPr sz="2000" b="0" lang="ja-JP">
-                <a:solidFill>
-                  <a:srgbClr val="303437"/>
-                </a:solidFill>
-                <a:latin typeface="Noto Sans"/>
-                <a:ea typeface="Noto Sans CJK JP"/>
-                <a:cs typeface="Noto Sans"/>
-              </a:defRPr>
-            </a:pPr>
-            <a:r>
-              <a:rPr sz="2000" b="0" lang="ja-JP">
-                <a:solidFill>
-                  <a:srgbClr val="303437"/>
-                </a:solidFill>
-                <a:latin typeface="Noto Sans"/>
-                <a:ea typeface="Noto Sans CJK JP"/>
-                <a:cs typeface="Noto Sans"/>
-              </a:rPr>
-              <a:t>文字列を手で画素数として読まず、APIで復元・面積計算を行う。</a:t>
             </a:r>
           </a:p>
         </p:txBody>
@@ -20840,7 +20774,7 @@
                 <a:ea typeface="Noto Sans CJK JP"/>
                 <a:cs typeface="Noto Sans"/>
               </a:rPr>
-              <a:t>2014年版のtrain 83K／val 41Kを、同じ画像で再分割した。2017は撮影年ではなく分割の公開年 [1]。</a:t>
+              <a:t>2017年に、2014年版のtrain 83K／val 41Kを同じ画像で再分割した [1]。</a:t>
             </a:r>
           </a:p>
         </p:txBody>
@@ -21071,41 +21005,6 @@
                 <a:cs typeface="Noto Sans"/>
               </a:rPr>
               <a:t>2017年版のtrain＋valは約123K画像。検出用の正解領域が公開されている。</a:t>
-            </a:r>
-          </a:p>
-          <a:p>
-            <a:pPr algn="l" lvl="0" marL="457200" indent="-355600">
-              <a:lnSpc>
-                <a:spcPct val="115000"/>
-              </a:lnSpc>
-              <a:spcBef>
-                <a:spcPts val="0"/>
-              </a:spcBef>
-              <a:spcAft>
-                <a:spcPts val="800"/>
-              </a:spcAft>
-              <a:buSzPct val="55417"/>
-              <a:buFont typeface="Noto Sans CJK JP"/>
-              <a:buChar char="●"/>
-              <a:defRPr lang="ja-JP" sz="2400" b="0">
-                <a:solidFill>
-                  <a:srgbClr val="303437"/>
-                </a:solidFill>
-                <a:latin typeface="Noto Sans"/>
-                <a:ea typeface="Noto Sans CJK JP"/>
-                <a:cs typeface="Noto Sans"/>
-              </a:defRPr>
-            </a:pPr>
-            <a:r>
-              <a:rPr lang="ja-JP" sz="2400" b="0">
-                <a:solidFill>
-                  <a:srgbClr val="303437"/>
-                </a:solidFill>
-                <a:latin typeface="Noto Sans"/>
-                <a:ea typeface="Noto Sans CJK JP"/>
-                <a:cs typeface="Noto Sans"/>
-              </a:rPr>
-              <a:t>全体規模の概数と、手元のtrain＋valで数える件数は対象範囲が異なる [1]。</a:t>
             </a:r>
           </a:p>
         </p:txBody>
@@ -25890,7 +25789,7 @@
                 <a:ea typeface="Noto Sans CJK JP"/>
                 <a:cs typeface="Noto Sans"/>
               </a:rPr>
-              <a:t>COCOの主指標APは、0.50から0.95まで0.05刻みの10閾値で求めたAPを平均する。1予測の合否を平均した値ではない。</a:t>
+              <a:t>COCOの主指標APは、0.50から0.95まで0.05刻みの10閾値で求めたAPを平均する。</a:t>
             </a:r>
           </a:p>
         </p:txBody>
@@ -26344,1165 +26243,6 @@
 </file>
 
 <file path=ppt/slides/slide42.xml><?xml version="1.0" encoding="utf-8"?>
-<p:sld xmlns:a="http://schemas.openxmlformats.org/drawingml/2006/main" xmlns:p="http://schemas.openxmlformats.org/presentationml/2006/main" xmlns:r="http://schemas.openxmlformats.org/officeDocument/2006/relationships">
-  <p:cSld>
-    <p:spTree>
-      <p:nvGrpSpPr>
-        <p:cNvPr id="1" name=""/>
-        <p:cNvGrpSpPr/>
-        <p:nvPr/>
-      </p:nvGrpSpPr>
-      <p:grpSpPr/>
-      <p:sp>
-        <p:nvSpPr>
-          <p:cNvPr id="2" name="Title 1"/>
-          <p:cNvSpPr>
-            <a:spLocks noGrp="1"/>
-          </p:cNvSpPr>
-          <p:nvPr>
-            <p:ph type="title"/>
-          </p:nvPr>
-        </p:nvSpPr>
-        <p:spPr>
-          <a:xfrm>
-            <a:off x="468172" y="650138"/>
-            <a:ext cx="8206740" cy="616305"/>
-          </a:xfrm>
-        </p:spPr>
-        <p:txBody>
-          <a:bodyPr wrap="none" anchor="t" lIns="0" rIns="0" tIns="0" bIns="0"/>
-          <a:lstStyle/>
-          <a:p>
-            <a:pPr algn="l">
-              <a:lnSpc>
-                <a:spcPct val="100000"/>
-              </a:lnSpc>
-              <a:spcBef>
-                <a:spcPts val="0"/>
-              </a:spcBef>
-              <a:spcAft>
-                <a:spcPts val="0"/>
-              </a:spcAft>
-              <a:buNone/>
-              <a:defRPr lang="ja-JP" sz="2800" b="1">
-                <a:solidFill>
-                  <a:srgbClr val="303437"/>
-                </a:solidFill>
-                <a:latin typeface="Noto Sans"/>
-                <a:ea typeface="Noto Sans CJK JP"/>
-                <a:cs typeface="Noto Sans"/>
-              </a:defRPr>
-            </a:pPr>
-            <a:r>
-              <a:rPr sz="2800" b="1" lang="ja-JP">
-                <a:solidFill>
-                  <a:srgbClr val="303437"/>
-                </a:solidFill>
-                <a:latin typeface="Noto Sans"/>
-                <a:ea typeface="Noto Sans CJK JP"/>
-                <a:cs typeface="Noto Sans"/>
-              </a:rPr>
-              <a:t>検出方式は領域候補を使うかどうかで異なる</a:t>
-            </a:r>
-          </a:p>
-        </p:txBody>
-      </p:sp>
-      <p:sp>
-        <p:nvSpPr>
-          <p:cNvPr id="3" name="Text Placeholder 2"/>
-          <p:cNvSpPr>
-            <a:spLocks noGrp="1"/>
-          </p:cNvSpPr>
-          <p:nvPr>
-            <p:ph type="body" idx="1"/>
-          </p:nvPr>
-        </p:nvSpPr>
-        <p:spPr>
-          <a:xfrm>
-            <a:off x="594360" y="1373852"/>
-            <a:ext cx="7955279" cy="3200400"/>
-          </a:xfrm>
-        </p:spPr>
-        <p:txBody>
-          <a:bodyPr wrap="square" anchor="t" tIns="91440" bIns="91440"/>
-          <a:lstStyle/>
-          <a:p>
-            <a:pPr algn="l" lvl="0" marL="457200" indent="-355600">
-              <a:lnSpc>
-                <a:spcPct val="110000"/>
-              </a:lnSpc>
-              <a:spcBef>
-                <a:spcPts val="0"/>
-              </a:spcBef>
-              <a:spcAft>
-                <a:spcPts val="700"/>
-              </a:spcAft>
-              <a:buSzPct val="63333"/>
-              <a:buFont typeface="Noto Sans CJK JP"/>
-              <a:buChar char="●"/>
-              <a:defRPr lang="ja-JP" sz="2100" b="0">
-                <a:solidFill>
-                  <a:srgbClr val="303437"/>
-                </a:solidFill>
-                <a:latin typeface="Noto Sans"/>
-                <a:ea typeface="Noto Sans CJK JP"/>
-                <a:cs typeface="Noto Sans"/>
-              </a:defRPr>
-            </a:pPr>
-            <a:r>
-              <a:rPr sz="2100" b="0" lang="ja-JP">
-                <a:solidFill>
-                  <a:srgbClr val="303437"/>
-                </a:solidFill>
-                <a:latin typeface="Noto Sans"/>
-                <a:ea typeface="Noto Sans CJK JP"/>
-                <a:cs typeface="Noto Sans"/>
-              </a:rPr>
-              <a:t>Faster R-CNN（2015）は候補領域を作り、その領域についてカテゴリと位置を推定する二段階方式である。</a:t>
-            </a:r>
-          </a:p>
-          <a:p>
-            <a:pPr algn="l" lvl="0" marL="457200" indent="-355600">
-              <a:lnSpc>
-                <a:spcPct val="110000"/>
-              </a:lnSpc>
-              <a:spcBef>
-                <a:spcPts val="0"/>
-              </a:spcBef>
-              <a:spcAft>
-                <a:spcPts val="700"/>
-              </a:spcAft>
-              <a:buSzPct val="63333"/>
-              <a:buFont typeface="Noto Sans CJK JP"/>
-              <a:buChar char="●"/>
-              <a:defRPr lang="ja-JP" sz="2100" b="0">
-                <a:solidFill>
-                  <a:srgbClr val="303437"/>
-                </a:solidFill>
-                <a:latin typeface="Noto Sans"/>
-                <a:ea typeface="Noto Sans CJK JP"/>
-                <a:cs typeface="Noto Sans"/>
-              </a:defRPr>
-            </a:pPr>
-            <a:r>
-              <a:rPr sz="2100" b="0" lang="ja-JP">
-                <a:solidFill>
-                  <a:srgbClr val="303437"/>
-                </a:solidFill>
-                <a:latin typeface="Noto Sans"/>
-                <a:ea typeface="Noto Sans CJK JP"/>
-                <a:cs typeface="Noto Sans"/>
-              </a:rPr>
-              <a:t>RetinaNet（2017）は画像上の多数の位置から直接検出する一段階方式で、学習中の易しい負例の影響を抑える。</a:t>
-            </a:r>
-          </a:p>
-          <a:p>
-            <a:pPr algn="l" lvl="0" marL="457200" indent="-355600">
-              <a:lnSpc>
-                <a:spcPct val="110000"/>
-              </a:lnSpc>
-              <a:spcBef>
-                <a:spcPts val="0"/>
-              </a:spcBef>
-              <a:spcAft>
-                <a:spcPts val="700"/>
-              </a:spcAft>
-              <a:buSzPct val="63333"/>
-              <a:buFont typeface="Noto Sans CJK JP"/>
-              <a:buChar char="●"/>
-              <a:defRPr lang="ja-JP" sz="2100" b="0">
-                <a:solidFill>
-                  <a:srgbClr val="303437"/>
-                </a:solidFill>
-                <a:latin typeface="Noto Sans"/>
-                <a:ea typeface="Noto Sans CJK JP"/>
-                <a:cs typeface="Noto Sans"/>
-              </a:defRPr>
-            </a:pPr>
-            <a:r>
-              <a:rPr sz="2100" b="0" lang="ja-JP">
-                <a:solidFill>
-                  <a:srgbClr val="303437"/>
-                </a:solidFill>
-                <a:latin typeface="Noto Sans"/>
-                <a:ea typeface="Noto Sans CJK JP"/>
-                <a:cs typeface="Noto Sans"/>
-              </a:rPr>
-              <a:t>RT-DETRv2（2024）は、物体間の関係を扱うTransformerを用いた実時間検出器RT-DETR（2023）を改良した。</a:t>
-            </a:r>
-          </a:p>
-        </p:txBody>
-      </p:sp>
-      <p:sp>
-        <p:nvSpPr>
-          <p:cNvPr id="4" name="Title 3"/>
-          <p:cNvSpPr>
-            <a:spLocks noGrp="1"/>
-          </p:cNvSpPr>
-          <p:nvPr>
-            <p:ph type="title" idx="2"/>
-          </p:nvPr>
-        </p:nvSpPr>
-        <p:spPr>
-          <a:xfrm>
-            <a:off x="75895" y="0"/>
-            <a:ext cx="8115300" cy="480060"/>
-          </a:xfrm>
-        </p:spPr>
-        <p:txBody>
-          <a:bodyPr wrap="square" anchor="ctr" lIns="0" rIns="0" tIns="0" bIns="0"/>
-          <a:lstStyle/>
-          <a:p>
-            <a:pPr algn="l">
-              <a:lnSpc>
-                <a:spcPct val="100000"/>
-              </a:lnSpc>
-              <a:spcBef>
-                <a:spcPts val="0"/>
-              </a:spcBef>
-              <a:spcAft>
-                <a:spcPts val="0"/>
-              </a:spcAft>
-              <a:buNone/>
-              <a:defRPr lang="ja-JP" sz="1400" b="1">
-                <a:solidFill>
-                  <a:srgbClr val="FFFEF8"/>
-                </a:solidFill>
-                <a:latin typeface="Noto Sans"/>
-                <a:ea typeface="Noto Sans CJK JP"/>
-                <a:cs typeface="Noto Sans"/>
-              </a:defRPr>
-            </a:pPr>
-            <a:r>
-              <a:rPr lang="ja-JP" sz="1400" b="1">
-                <a:solidFill>
-                  <a:srgbClr val="FFFEF8"/>
-                </a:solidFill>
-                <a:latin typeface="Noto Sans"/>
-                <a:ea typeface="Noto Sans CJK JP"/>
-                <a:cs typeface="Noto Sans"/>
-              </a:rPr>
-              <a:t>3. 物体検出・領域分割の評価とモデル性能</a:t>
-            </a:r>
-          </a:p>
-        </p:txBody>
-      </p:sp>
-      <p:sp>
-        <p:nvSpPr>
-          <p:cNvPr id="5" name="TextBox 4"/>
-          <p:cNvSpPr txBox="1"/>
-          <p:nvPr/>
-        </p:nvSpPr>
-        <p:spPr>
-          <a:xfrm>
-            <a:off x="502920" y="3987799"/>
-            <a:ext cx="8183879" cy="177800"/>
-          </a:xfrm>
-          <a:prstGeom prst="rect">
-            <a:avLst/>
-          </a:prstGeom>
-          <a:noFill/>
-        </p:spPr>
-        <p:txBody>
-          <a:bodyPr wrap="square" lIns="0" rIns="0" tIns="0" bIns="0">
-            <a:spAutoFit/>
-          </a:bodyPr>
-          <a:lstStyle/>
-          <a:p>
-            <a:pPr algn="l">
-              <a:lnSpc>
-                <a:spcPts val="1400"/>
-              </a:lnSpc>
-              <a:spcBef>
-                <a:spcPts val="0"/>
-              </a:spcBef>
-              <a:spcAft>
-                <a:spcPts val="0"/>
-              </a:spcAft>
-            </a:pPr>
-            <a:r>
-              <a:rPr sz="800" b="0" lang="ja-JP">
-                <a:solidFill>
-                  <a:srgbClr val="626669"/>
-                </a:solidFill>
-                <a:latin typeface="Noto Sans"/>
-                <a:ea typeface="Noto Sans CJK JP"/>
-                <a:cs typeface="Noto Sans"/>
-              </a:rPr>
-              <a:t/>
-            </a:r>
-            <a:r>
-              <a:rPr sz="800" lang="ja-JP">
-                <a:solidFill>
-                  <a:srgbClr val="626669"/>
-                </a:solidFill>
-                <a:latin typeface="Noto Sans"/>
-                <a:ea typeface="Noto Sans CJK JP"/>
-                <a:cs typeface="Noto Sans"/>
-              </a:rPr>
-              <a:t>[1] Ren et al. (2015). NeurIPS. Faster R-CNN: Towards Real-Time Object Detection with Region Proposal Networks.</a:t>
-            </a:r>
-          </a:p>
-        </p:txBody>
-      </p:sp>
-      <p:sp>
-        <p:nvSpPr>
-          <p:cNvPr id="6" name="TextBox 5"/>
-          <p:cNvSpPr txBox="1"/>
-          <p:nvPr/>
-        </p:nvSpPr>
-        <p:spPr>
-          <a:xfrm>
-            <a:off x="5928392" y="4006114"/>
-            <a:ext cx="2758407" cy="177800"/>
-          </a:xfrm>
-          <a:prstGeom prst="rect">
-            <a:avLst/>
-          </a:prstGeom>
-          <a:noFill/>
-        </p:spPr>
-        <p:txBody>
-          <a:bodyPr wrap="none" lIns="0" rIns="0" tIns="0" bIns="0">
-            <a:spAutoFit/>
-          </a:bodyPr>
-          <a:lstStyle/>
-          <a:p>
-            <a:pPr algn="l">
-              <a:lnSpc>
-                <a:spcPts val="1400"/>
-              </a:lnSpc>
-              <a:spcBef>
-                <a:spcPts val="0"/>
-              </a:spcBef>
-              <a:spcAft>
-                <a:spcPts val="0"/>
-              </a:spcAft>
-            </a:pPr>
-            <a:r>
-              <a:rPr sz="800" b="0" lang="ja-JP">
-                <a:solidFill>
-                  <a:srgbClr val="626669"/>
-                </a:solidFill>
-                <a:latin typeface="Noto Sans"/>
-                <a:ea typeface="Noto Sans CJK JP"/>
-                <a:cs typeface="Noto Sans"/>
-              </a:rPr>
-              <a:t/>
-            </a:r>
-            <a:r>
-              <a:rPr sz="800" lang="ja-JP">
-                <a:solidFill>
-                  <a:srgbClr val="626669"/>
-                </a:solidFill>
-                <a:latin typeface="Noto Sans"/>
-                <a:ea typeface="Noto Sans CJK JP"/>
-                <a:cs typeface="Noto Sans"/>
-                <a:hlinkClick r:id="rId3"/>
-              </a:rPr>
-              <a:t>https://arxiv.org/abs/1506.01497</a:t>
-            </a:r>
-          </a:p>
-        </p:txBody>
-      </p:sp>
-      <p:sp>
-        <p:nvSpPr>
-          <p:cNvPr id="7" name="TextBox 6"/>
-          <p:cNvSpPr txBox="1"/>
-          <p:nvPr/>
-        </p:nvSpPr>
-        <p:spPr>
-          <a:xfrm>
-            <a:off x="502920" y="4343400"/>
-            <a:ext cx="8183879" cy="177800"/>
-          </a:xfrm>
-          <a:prstGeom prst="rect">
-            <a:avLst/>
-          </a:prstGeom>
-          <a:noFill/>
-        </p:spPr>
-        <p:txBody>
-          <a:bodyPr wrap="square" lIns="0" rIns="0" tIns="0" bIns="0">
-            <a:spAutoFit/>
-          </a:bodyPr>
-          <a:lstStyle/>
-          <a:p>
-            <a:pPr algn="l">
-              <a:lnSpc>
-                <a:spcPts val="1400"/>
-              </a:lnSpc>
-              <a:spcBef>
-                <a:spcPts val="0"/>
-              </a:spcBef>
-              <a:spcAft>
-                <a:spcPts val="0"/>
-              </a:spcAft>
-            </a:pPr>
-            <a:r>
-              <a:rPr sz="800" b="0" lang="ja-JP">
-                <a:solidFill>
-                  <a:srgbClr val="626669"/>
-                </a:solidFill>
-                <a:latin typeface="Noto Sans"/>
-                <a:ea typeface="Noto Sans CJK JP"/>
-                <a:cs typeface="Noto Sans"/>
-              </a:rPr>
-              <a:t/>
-            </a:r>
-            <a:r>
-              <a:rPr sz="800" lang="ja-JP">
-                <a:solidFill>
-                  <a:srgbClr val="626669"/>
-                </a:solidFill>
-                <a:latin typeface="Noto Sans"/>
-                <a:ea typeface="Noto Sans CJK JP"/>
-                <a:cs typeface="Noto Sans"/>
-              </a:rPr>
-              <a:t>[2] Lin et al. (2017). ICCV. Focal Loss for Dense Object Detection.</a:t>
-            </a:r>
-          </a:p>
-        </p:txBody>
-      </p:sp>
-      <p:sp>
-        <p:nvSpPr>
-          <p:cNvPr id="8" name="TextBox 7"/>
-          <p:cNvSpPr txBox="1"/>
-          <p:nvPr/>
-        </p:nvSpPr>
-        <p:spPr>
-          <a:xfrm>
-            <a:off x="3583598" y="4361713"/>
-            <a:ext cx="5103201" cy="177800"/>
-          </a:xfrm>
-          <a:prstGeom prst="rect">
-            <a:avLst/>
-          </a:prstGeom>
-          <a:noFill/>
-        </p:spPr>
-        <p:txBody>
-          <a:bodyPr wrap="none" lIns="0" rIns="0" tIns="0" bIns="0">
-            <a:spAutoFit/>
-          </a:bodyPr>
-          <a:lstStyle/>
-          <a:p>
-            <a:pPr algn="l">
-              <a:lnSpc>
-                <a:spcPts val="1400"/>
-              </a:lnSpc>
-              <a:spcBef>
-                <a:spcPts val="0"/>
-              </a:spcBef>
-              <a:spcAft>
-                <a:spcPts val="0"/>
-              </a:spcAft>
-            </a:pPr>
-            <a:r>
-              <a:rPr sz="800" b="0" lang="ja-JP">
-                <a:solidFill>
-                  <a:srgbClr val="626669"/>
-                </a:solidFill>
-                <a:latin typeface="Noto Sans"/>
-                <a:ea typeface="Noto Sans CJK JP"/>
-                <a:cs typeface="Noto Sans"/>
-              </a:rPr>
-              <a:t/>
-            </a:r>
-            <a:r>
-              <a:rPr sz="800" lang="ja-JP">
-                <a:solidFill>
-                  <a:srgbClr val="626669"/>
-                </a:solidFill>
-                <a:latin typeface="Noto Sans"/>
-                <a:ea typeface="Noto Sans CJK JP"/>
-                <a:cs typeface="Noto Sans"/>
-                <a:hlinkClick r:id="rId4"/>
-              </a:rPr>
-              <a:t>https://arxiv.org/abs/1708.02002</a:t>
-            </a:r>
-          </a:p>
-        </p:txBody>
-      </p:sp>
-      <p:sp>
-        <p:nvSpPr>
-          <p:cNvPr id="9" name="TextBox 8"/>
-          <p:cNvSpPr txBox="1"/>
-          <p:nvPr/>
-        </p:nvSpPr>
-        <p:spPr>
-          <a:xfrm>
-            <a:off x="502920" y="4699000"/>
-            <a:ext cx="8183879" cy="177800"/>
-          </a:xfrm>
-          <a:prstGeom prst="rect">
-            <a:avLst/>
-          </a:prstGeom>
-          <a:noFill/>
-        </p:spPr>
-        <p:txBody>
-          <a:bodyPr wrap="square" lIns="0" rIns="0" tIns="0" bIns="0">
-            <a:spAutoFit/>
-          </a:bodyPr>
-          <a:lstStyle/>
-          <a:p>
-            <a:pPr algn="l">
-              <a:lnSpc>
-                <a:spcPts val="1400"/>
-              </a:lnSpc>
-              <a:spcBef>
-                <a:spcPts val="0"/>
-              </a:spcBef>
-              <a:spcAft>
-                <a:spcPts val="0"/>
-              </a:spcAft>
-            </a:pPr>
-            <a:r>
-              <a:rPr sz="800" b="0" lang="ja-JP">
-                <a:solidFill>
-                  <a:srgbClr val="626669"/>
-                </a:solidFill>
-                <a:latin typeface="Noto Sans"/>
-                <a:ea typeface="Noto Sans CJK JP"/>
-                <a:cs typeface="Noto Sans"/>
-              </a:rPr>
-              <a:t/>
-            </a:r>
-            <a:r>
-              <a:rPr sz="800" lang="ja-JP">
-                <a:solidFill>
-                  <a:srgbClr val="626669"/>
-                </a:solidFill>
-                <a:latin typeface="Noto Sans"/>
-                <a:ea typeface="Noto Sans CJK JP"/>
-                <a:cs typeface="Noto Sans"/>
-              </a:rPr>
-              <a:t>[3] Lv et al. (2024). arXiv:2407.17140. RT-DETRv2: Improved Baseline with Bag-of-Freebies for Real-Time Detection Transformer.</a:t>
-            </a:r>
-          </a:p>
-        </p:txBody>
-      </p:sp>
-      <p:sp>
-        <p:nvSpPr>
-          <p:cNvPr id="10" name="TextBox 9"/>
-          <p:cNvSpPr txBox="1"/>
-          <p:nvPr/>
-        </p:nvSpPr>
-        <p:spPr>
-          <a:xfrm>
-            <a:off x="6558753" y="4717326"/>
-            <a:ext cx="2128046" cy="177800"/>
-          </a:xfrm>
-          <a:prstGeom prst="rect">
-            <a:avLst/>
-          </a:prstGeom>
-          <a:noFill/>
-        </p:spPr>
-        <p:txBody>
-          <a:bodyPr wrap="none" lIns="0" rIns="0" tIns="0" bIns="0">
-            <a:spAutoFit/>
-          </a:bodyPr>
-          <a:lstStyle/>
-          <a:p>
-            <a:pPr algn="l">
-              <a:lnSpc>
-                <a:spcPts val="1400"/>
-              </a:lnSpc>
-              <a:spcBef>
-                <a:spcPts val="0"/>
-              </a:spcBef>
-              <a:spcAft>
-                <a:spcPts val="0"/>
-              </a:spcAft>
-            </a:pPr>
-            <a:r>
-              <a:rPr sz="800" b="0" lang="ja-JP">
-                <a:solidFill>
-                  <a:srgbClr val="626669"/>
-                </a:solidFill>
-                <a:latin typeface="Noto Sans"/>
-                <a:ea typeface="Noto Sans CJK JP"/>
-                <a:cs typeface="Noto Sans"/>
-              </a:rPr>
-              <a:t/>
-            </a:r>
-            <a:r>
-              <a:rPr sz="800" lang="ja-JP">
-                <a:solidFill>
-                  <a:srgbClr val="626669"/>
-                </a:solidFill>
-                <a:latin typeface="Noto Sans"/>
-                <a:ea typeface="Noto Sans CJK JP"/>
-                <a:cs typeface="Noto Sans"/>
-                <a:hlinkClick r:id="rId2"/>
-              </a:rPr>
-              <a:t>https://arxiv.org/abs/2407.17140</a:t>
-            </a:r>
-          </a:p>
-        </p:txBody>
-      </p:sp>
-    </p:spTree>
-  </p:cSld>
-  <p:clrMapOvr>
-    <a:masterClrMapping/>
-  </p:clrMapOvr>
-</p:sld>
-</file>
-
-<file path=ppt/slides/slide43.xml><?xml version="1.0" encoding="utf-8"?>
-<p:sld xmlns:a="http://schemas.openxmlformats.org/drawingml/2006/main" xmlns:p="http://schemas.openxmlformats.org/presentationml/2006/main" xmlns:r="http://schemas.openxmlformats.org/officeDocument/2006/relationships">
-  <p:cSld>
-    <p:spTree>
-      <p:nvGrpSpPr>
-        <p:cNvPr id="1" name=""/>
-        <p:cNvGrpSpPr/>
-        <p:nvPr/>
-      </p:nvGrpSpPr>
-      <p:grpSpPr/>
-      <p:sp>
-        <p:nvSpPr>
-          <p:cNvPr id="2" name="Title 1"/>
-          <p:cNvSpPr>
-            <a:spLocks noGrp="1"/>
-          </p:cNvSpPr>
-          <p:nvPr>
-            <p:ph type="title"/>
-          </p:nvPr>
-        </p:nvSpPr>
-        <p:spPr>
-          <a:xfrm>
-            <a:off x="468172" y="650138"/>
-            <a:ext cx="8206740" cy="616305"/>
-          </a:xfrm>
-        </p:spPr>
-        <p:txBody>
-          <a:bodyPr wrap="none" anchor="t" lIns="0" rIns="0" tIns="0" bIns="0"/>
-          <a:lstStyle/>
-          <a:p>
-            <a:pPr algn="l">
-              <a:lnSpc>
-                <a:spcPct val="100000"/>
-              </a:lnSpc>
-              <a:spcBef>
-                <a:spcPts val="0"/>
-              </a:spcBef>
-              <a:spcAft>
-                <a:spcPts val="0"/>
-              </a:spcAft>
-              <a:buNone/>
-              <a:defRPr lang="ja-JP" sz="2800" b="1">
-                <a:solidFill>
-                  <a:srgbClr val="303437"/>
-                </a:solidFill>
-                <a:latin typeface="Noto Sans"/>
-                <a:ea typeface="Noto Sans CJK JP"/>
-                <a:cs typeface="Noto Sans"/>
-              </a:defRPr>
-            </a:pPr>
-            <a:r>
-              <a:rPr sz="2800" b="1" lang="ja-JP">
-                <a:solidFill>
-                  <a:srgbClr val="303437"/>
-                </a:solidFill>
-                <a:latin typeface="Noto Sans"/>
-                <a:ea typeface="Noto Sans CJK JP"/>
-                <a:cs typeface="Noto Sans"/>
-              </a:rPr>
-              <a:t>R50・FPN・3xはモデルと学習設定を表す</a:t>
-            </a:r>
-          </a:p>
-        </p:txBody>
-      </p:sp>
-      <p:sp>
-        <p:nvSpPr>
-          <p:cNvPr id="3" name="Text Placeholder 2"/>
-          <p:cNvSpPr>
-            <a:spLocks noGrp="1"/>
-          </p:cNvSpPr>
-          <p:nvPr>
-            <p:ph type="body" idx="1"/>
-          </p:nvPr>
-        </p:nvSpPr>
-        <p:spPr>
-          <a:xfrm>
-            <a:off x="594360" y="1301097"/>
-            <a:ext cx="7955279" cy="3200400"/>
-          </a:xfrm>
-        </p:spPr>
-        <p:txBody>
-          <a:bodyPr wrap="square" anchor="t" tIns="91440" bIns="91440"/>
-          <a:lstStyle/>
-          <a:p>
-            <a:pPr algn="l" lvl="0" marL="457200" indent="-355600">
-              <a:lnSpc>
-                <a:spcPct val="115000"/>
-              </a:lnSpc>
-              <a:spcBef>
-                <a:spcPts val="0"/>
-              </a:spcBef>
-              <a:spcAft>
-                <a:spcPts val="1000"/>
-              </a:spcAft>
-              <a:buSzPct val="57826"/>
-              <a:buFont typeface="Noto Sans CJK JP"/>
-              <a:buChar char="●"/>
-              <a:defRPr lang="ja-JP" sz="2300" b="0">
-                <a:solidFill>
-                  <a:srgbClr val="303437"/>
-                </a:solidFill>
-                <a:latin typeface="Noto Sans"/>
-                <a:ea typeface="Noto Sans CJK JP"/>
-                <a:cs typeface="Noto Sans"/>
-              </a:defRPr>
-            </a:pPr>
-            <a:r>
-              <a:rPr sz="2300" b="0" lang="ja-JP">
-                <a:solidFill>
-                  <a:srgbClr val="303437"/>
-                </a:solidFill>
-                <a:latin typeface="Noto Sans"/>
-                <a:ea typeface="Noto Sans CJK JP"/>
-                <a:cs typeface="Noto Sans"/>
-              </a:rPr>
-              <a:t>R50は、画像から特徴を抽出する50層のResNet-50（2016）を指す。</a:t>
-            </a:r>
-          </a:p>
-          <a:p>
-            <a:pPr algn="l" lvl="0" marL="457200" indent="-355600">
-              <a:lnSpc>
-                <a:spcPct val="115000"/>
-              </a:lnSpc>
-              <a:spcBef>
-                <a:spcPts val="0"/>
-              </a:spcBef>
-              <a:spcAft>
-                <a:spcPts val="1000"/>
-              </a:spcAft>
-              <a:buSzPct val="57826"/>
-              <a:buFont typeface="Noto Sans CJK JP"/>
-              <a:buChar char="●"/>
-              <a:defRPr lang="ja-JP" sz="2300" b="0">
-                <a:solidFill>
-                  <a:srgbClr val="303437"/>
-                </a:solidFill>
-                <a:latin typeface="Noto Sans"/>
-                <a:ea typeface="Noto Sans CJK JP"/>
-                <a:cs typeface="Noto Sans"/>
-              </a:defRPr>
-            </a:pPr>
-            <a:r>
-              <a:rPr sz="2300" b="0" lang="ja-JP">
-                <a:solidFill>
-                  <a:srgbClr val="303437"/>
-                </a:solidFill>
-                <a:latin typeface="Noto Sans"/>
-                <a:ea typeface="Noto Sans CJK JP"/>
-                <a:cs typeface="Noto Sans"/>
-              </a:rPr>
-              <a:t>FPNは、異なる解像度の特徴を統合するFeature Pyramid Networks（2017）を指す。</a:t>
-            </a:r>
-          </a:p>
-          <a:p>
-            <a:pPr algn="l" lvl="0" marL="457200" indent="-355600">
-              <a:lnSpc>
-                <a:spcPct val="115000"/>
-              </a:lnSpc>
-              <a:spcBef>
-                <a:spcPts val="0"/>
-              </a:spcBef>
-              <a:spcAft>
-                <a:spcPts val="1000"/>
-              </a:spcAft>
-              <a:buSzPct val="57826"/>
-              <a:buFont typeface="Noto Sans CJK JP"/>
-              <a:buChar char="●"/>
-              <a:defRPr lang="ja-JP" sz="2300" b="0">
-                <a:solidFill>
-                  <a:srgbClr val="303437"/>
-                </a:solidFill>
-                <a:latin typeface="Noto Sans"/>
-                <a:ea typeface="Noto Sans CJK JP"/>
-                <a:cs typeface="Noto Sans"/>
-              </a:defRPr>
-            </a:pPr>
-            <a:r>
-              <a:rPr sz="2300" b="0" lang="ja-JP">
-                <a:solidFill>
-                  <a:srgbClr val="303437"/>
-                </a:solidFill>
-                <a:latin typeface="Noto Sans"/>
-                <a:ea typeface="Noto Sans CJK JP"/>
-                <a:cs typeface="Noto Sans"/>
-              </a:rPr>
-              <a:t>3xは公開実装の学習スケジュール名で、標準的な1xより長く学習する設定を示す。モデルの発表年ではない。</a:t>
-            </a:r>
-          </a:p>
-        </p:txBody>
-      </p:sp>
-      <p:sp>
-        <p:nvSpPr>
-          <p:cNvPr id="4" name="Title 3"/>
-          <p:cNvSpPr>
-            <a:spLocks noGrp="1"/>
-          </p:cNvSpPr>
-          <p:nvPr>
-            <p:ph type="title" idx="2"/>
-          </p:nvPr>
-        </p:nvSpPr>
-        <p:spPr>
-          <a:xfrm>
-            <a:off x="75895" y="0"/>
-            <a:ext cx="8115300" cy="480060"/>
-          </a:xfrm>
-        </p:spPr>
-        <p:txBody>
-          <a:bodyPr wrap="square" anchor="ctr" lIns="0" rIns="0" tIns="0" bIns="0"/>
-          <a:lstStyle/>
-          <a:p>
-            <a:pPr algn="l">
-              <a:lnSpc>
-                <a:spcPct val="100000"/>
-              </a:lnSpc>
-              <a:spcBef>
-                <a:spcPts val="0"/>
-              </a:spcBef>
-              <a:spcAft>
-                <a:spcPts val="0"/>
-              </a:spcAft>
-              <a:buNone/>
-              <a:defRPr lang="ja-JP" sz="1400" b="1">
-                <a:solidFill>
-                  <a:srgbClr val="FFFEF8"/>
-                </a:solidFill>
-                <a:latin typeface="Noto Sans"/>
-                <a:ea typeface="Noto Sans CJK JP"/>
-                <a:cs typeface="Noto Sans"/>
-              </a:defRPr>
-            </a:pPr>
-            <a:r>
-              <a:rPr lang="ja-JP" sz="1400" b="1">
-                <a:solidFill>
-                  <a:srgbClr val="FFFEF8"/>
-                </a:solidFill>
-                <a:latin typeface="Noto Sans"/>
-                <a:ea typeface="Noto Sans CJK JP"/>
-                <a:cs typeface="Noto Sans"/>
-              </a:rPr>
-              <a:t>3. 物体検出・領域分割の評価とモデル性能</a:t>
-            </a:r>
-          </a:p>
-        </p:txBody>
-      </p:sp>
-      <p:sp>
-        <p:nvSpPr>
-          <p:cNvPr id="5" name="TextBox 4"/>
-          <p:cNvSpPr txBox="1"/>
-          <p:nvPr/>
-        </p:nvSpPr>
-        <p:spPr>
-          <a:xfrm>
-            <a:off x="502920" y="4165600"/>
-            <a:ext cx="8183879" cy="177800"/>
-          </a:xfrm>
-          <a:prstGeom prst="rect">
-            <a:avLst/>
-          </a:prstGeom>
-          <a:noFill/>
-        </p:spPr>
-        <p:txBody>
-          <a:bodyPr wrap="square" lIns="0" rIns="0" tIns="0" bIns="0">
-            <a:spAutoFit/>
-          </a:bodyPr>
-          <a:lstStyle/>
-          <a:p>
-            <a:pPr algn="l">
-              <a:lnSpc>
-                <a:spcPts val="1400"/>
-              </a:lnSpc>
-              <a:spcBef>
-                <a:spcPts val="0"/>
-              </a:spcBef>
-              <a:spcAft>
-                <a:spcPts val="0"/>
-              </a:spcAft>
-            </a:pPr>
-            <a:r>
-              <a:rPr sz="800" b="0" lang="ja-JP">
-                <a:solidFill>
-                  <a:srgbClr val="626669"/>
-                </a:solidFill>
-                <a:latin typeface="Noto Sans"/>
-                <a:ea typeface="Noto Sans CJK JP"/>
-                <a:cs typeface="Noto Sans"/>
-              </a:rPr>
-              <a:t/>
-            </a:r>
-            <a:r>
-              <a:rPr sz="800" lang="ja-JP">
-                <a:solidFill>
-                  <a:srgbClr val="626669"/>
-                </a:solidFill>
-                <a:latin typeface="Noto Sans"/>
-                <a:ea typeface="Noto Sans CJK JP"/>
-                <a:cs typeface="Noto Sans"/>
-              </a:rPr>
-              <a:t>[1] He et al. (2016). CVPR, pp. 770–778. Deep Residual Learning for Image Recognition.</a:t>
-            </a:r>
-          </a:p>
-        </p:txBody>
-      </p:sp>
-      <p:sp>
-        <p:nvSpPr>
-          <p:cNvPr id="6" name="TextBox 5"/>
-          <p:cNvSpPr txBox="1"/>
-          <p:nvPr/>
-        </p:nvSpPr>
-        <p:spPr>
-          <a:xfrm>
-            <a:off x="4664725" y="4183913"/>
-            <a:ext cx="4022074" cy="177800"/>
-          </a:xfrm>
-          <a:prstGeom prst="rect">
-            <a:avLst/>
-          </a:prstGeom>
-          <a:noFill/>
-        </p:spPr>
-        <p:txBody>
-          <a:bodyPr wrap="none" lIns="0" rIns="0" tIns="0" bIns="0">
-            <a:spAutoFit/>
-          </a:bodyPr>
-          <a:lstStyle/>
-          <a:p>
-            <a:pPr algn="l">
-              <a:lnSpc>
-                <a:spcPts val="1400"/>
-              </a:lnSpc>
-              <a:spcBef>
-                <a:spcPts val="0"/>
-              </a:spcBef>
-              <a:spcAft>
-                <a:spcPts val="0"/>
-              </a:spcAft>
-            </a:pPr>
-            <a:r>
-              <a:rPr sz="800" b="0" lang="ja-JP">
-                <a:solidFill>
-                  <a:srgbClr val="626669"/>
-                </a:solidFill>
-                <a:latin typeface="Noto Sans"/>
-                <a:ea typeface="Noto Sans CJK JP"/>
-                <a:cs typeface="Noto Sans"/>
-              </a:rPr>
-              <a:t/>
-            </a:r>
-            <a:r>
-              <a:rPr sz="800" lang="ja-JP">
-                <a:solidFill>
-                  <a:srgbClr val="626669"/>
-                </a:solidFill>
-                <a:latin typeface="Noto Sans"/>
-                <a:ea typeface="Noto Sans CJK JP"/>
-                <a:cs typeface="Noto Sans"/>
-                <a:hlinkClick r:id="rId3"/>
-              </a:rPr>
-              <a:t>https://arxiv.org/abs/1512.03385</a:t>
-            </a:r>
-          </a:p>
-        </p:txBody>
-      </p:sp>
-      <p:sp>
-        <p:nvSpPr>
-          <p:cNvPr id="7" name="TextBox 6"/>
-          <p:cNvSpPr txBox="1"/>
-          <p:nvPr/>
-        </p:nvSpPr>
-        <p:spPr>
-          <a:xfrm>
-            <a:off x="502920" y="4521200"/>
-            <a:ext cx="8183879" cy="177800"/>
-          </a:xfrm>
-          <a:prstGeom prst="rect">
-            <a:avLst/>
-          </a:prstGeom>
-          <a:noFill/>
-        </p:spPr>
-        <p:txBody>
-          <a:bodyPr wrap="square" lIns="0" rIns="0" tIns="0" bIns="0">
-            <a:spAutoFit/>
-          </a:bodyPr>
-          <a:lstStyle/>
-          <a:p>
-            <a:pPr algn="l">
-              <a:lnSpc>
-                <a:spcPts val="1400"/>
-              </a:lnSpc>
-              <a:spcBef>
-                <a:spcPts val="0"/>
-              </a:spcBef>
-              <a:spcAft>
-                <a:spcPts val="0"/>
-              </a:spcAft>
-            </a:pPr>
-            <a:r>
-              <a:rPr sz="800" b="0" lang="ja-JP">
-                <a:solidFill>
-                  <a:srgbClr val="626669"/>
-                </a:solidFill>
-                <a:latin typeface="Noto Sans"/>
-                <a:ea typeface="Noto Sans CJK JP"/>
-                <a:cs typeface="Noto Sans"/>
-              </a:rPr>
-              <a:t/>
-            </a:r>
-            <a:r>
-              <a:rPr sz="800" lang="ja-JP">
-                <a:solidFill>
-                  <a:srgbClr val="626669"/>
-                </a:solidFill>
-                <a:latin typeface="Noto Sans"/>
-                <a:ea typeface="Noto Sans CJK JP"/>
-                <a:cs typeface="Noto Sans"/>
-              </a:rPr>
-              <a:t>[2] Lin et al. (2017). CVPR. Feature Pyramid Networks for Object Detection.</a:t>
-            </a:r>
-          </a:p>
-        </p:txBody>
-      </p:sp>
-      <p:sp>
-        <p:nvSpPr>
-          <p:cNvPr id="8" name="TextBox 7"/>
-          <p:cNvSpPr txBox="1"/>
-          <p:nvPr/>
-        </p:nvSpPr>
-        <p:spPr>
-          <a:xfrm>
-            <a:off x="4074365" y="4539526"/>
-            <a:ext cx="4612434" cy="177800"/>
-          </a:xfrm>
-          <a:prstGeom prst="rect">
-            <a:avLst/>
-          </a:prstGeom>
-          <a:noFill/>
-        </p:spPr>
-        <p:txBody>
-          <a:bodyPr wrap="none" lIns="0" rIns="0" tIns="0" bIns="0">
-            <a:spAutoFit/>
-          </a:bodyPr>
-          <a:lstStyle/>
-          <a:p>
-            <a:pPr algn="l">
-              <a:lnSpc>
-                <a:spcPts val="1400"/>
-              </a:lnSpc>
-              <a:spcBef>
-                <a:spcPts val="0"/>
-              </a:spcBef>
-              <a:spcAft>
-                <a:spcPts val="0"/>
-              </a:spcAft>
-            </a:pPr>
-            <a:r>
-              <a:rPr sz="800" b="0" lang="ja-JP">
-                <a:solidFill>
-                  <a:srgbClr val="626669"/>
-                </a:solidFill>
-                <a:latin typeface="Noto Sans"/>
-                <a:ea typeface="Noto Sans CJK JP"/>
-                <a:cs typeface="Noto Sans"/>
-              </a:rPr>
-              <a:t/>
-            </a:r>
-            <a:r>
-              <a:rPr sz="800" lang="ja-JP">
-                <a:solidFill>
-                  <a:srgbClr val="626669"/>
-                </a:solidFill>
-                <a:latin typeface="Noto Sans"/>
-                <a:ea typeface="Noto Sans CJK JP"/>
-                <a:cs typeface="Noto Sans"/>
-                <a:hlinkClick r:id="rId4"/>
-              </a:rPr>
-              <a:t>https://arxiv.org/abs/1612.03144</a:t>
-            </a:r>
-          </a:p>
-        </p:txBody>
-      </p:sp>
-      <p:sp>
-        <p:nvSpPr>
-          <p:cNvPr id="9" name="TextBox 8"/>
-          <p:cNvSpPr txBox="1"/>
-          <p:nvPr/>
-        </p:nvSpPr>
-        <p:spPr>
-          <a:xfrm>
-            <a:off x="502920" y="4876800"/>
-            <a:ext cx="8183879" cy="177800"/>
-          </a:xfrm>
-          <a:prstGeom prst="rect">
-            <a:avLst/>
-          </a:prstGeom>
-          <a:noFill/>
-        </p:spPr>
-        <p:txBody>
-          <a:bodyPr wrap="square" lIns="0" rIns="0" tIns="0" bIns="0">
-            <a:spAutoFit/>
-          </a:bodyPr>
-          <a:lstStyle/>
-          <a:p>
-            <a:pPr algn="l">
-              <a:lnSpc>
-                <a:spcPts val="1400"/>
-              </a:lnSpc>
-              <a:spcBef>
-                <a:spcPts val="0"/>
-              </a:spcBef>
-              <a:spcAft>
-                <a:spcPts val="0"/>
-              </a:spcAft>
-            </a:pPr>
-            <a:r>
-              <a:rPr sz="800" b="0" lang="ja-JP">
-                <a:solidFill>
-                  <a:srgbClr val="626669"/>
-                </a:solidFill>
-                <a:latin typeface="Noto Sans"/>
-                <a:ea typeface="Noto Sans CJK JP"/>
-                <a:cs typeface="Noto Sans"/>
-              </a:rPr>
-              <a:t/>
-            </a:r>
-            <a:r>
-              <a:rPr sz="800" lang="ja-JP">
-                <a:solidFill>
-                  <a:srgbClr val="626669"/>
-                </a:solidFill>
-                <a:latin typeface="Noto Sans"/>
-                <a:ea typeface="Noto Sans CJK JP"/>
-                <a:cs typeface="Noto Sans"/>
-              </a:rPr>
-              <a:t>[3] </a:t>
-            </a:r>
-            <a:r>
-              <a:rPr sz="800" lang="ja-JP">
-                <a:solidFill>
-                  <a:srgbClr val="626669"/>
-                </a:solidFill>
-                <a:latin typeface="Noto Sans"/>
-                <a:ea typeface="Noto Sans CJK JP"/>
-                <a:cs typeface="Noto Sans"/>
-                <a:hlinkClick r:id="rId2"/>
-              </a:rPr>
-              <a:t>https://github.com/facebookresearch/detectron2/blob/main/MODEL_ZOO.md</a:t>
-            </a:r>
-          </a:p>
-        </p:txBody>
-      </p:sp>
-    </p:spTree>
-  </p:cSld>
-  <p:clrMapOvr>
-    <a:masterClrMapping/>
-  </p:clrMapOvr>
-</p:sld>
-</file>
-
-<file path=ppt/slides/slide44.xml><?xml version="1.0" encoding="utf-8"?>
 <p:sld xmlns:a="http://schemas.openxmlformats.org/drawingml/2006/main" xmlns:p="http://schemas.openxmlformats.org/presentationml/2006/main" xmlns:r="http://schemas.openxmlformats.org/officeDocument/2006/relationships">
   <p:cSld>
     <p:spTree>
@@ -28773,6 +27513,1165 @@
 </p:sld>
 </file>
 
+<file path=ppt/slides/slide43.xml><?xml version="1.0" encoding="utf-8"?>
+<p:sld xmlns:a="http://schemas.openxmlformats.org/drawingml/2006/main" xmlns:p="http://schemas.openxmlformats.org/presentationml/2006/main" xmlns:r="http://schemas.openxmlformats.org/officeDocument/2006/relationships">
+  <p:cSld>
+    <p:spTree>
+      <p:nvGrpSpPr>
+        <p:cNvPr id="1" name=""/>
+        <p:cNvGrpSpPr/>
+        <p:nvPr/>
+      </p:nvGrpSpPr>
+      <p:grpSpPr/>
+      <p:sp>
+        <p:nvSpPr>
+          <p:cNvPr id="2" name="Title 1"/>
+          <p:cNvSpPr>
+            <a:spLocks noGrp="1"/>
+          </p:cNvSpPr>
+          <p:nvPr>
+            <p:ph type="title"/>
+          </p:nvPr>
+        </p:nvSpPr>
+        <p:spPr>
+          <a:xfrm>
+            <a:off x="468172" y="650138"/>
+            <a:ext cx="8206740" cy="616305"/>
+          </a:xfrm>
+        </p:spPr>
+        <p:txBody>
+          <a:bodyPr wrap="none" anchor="t" lIns="0" rIns="0" tIns="0" bIns="0"/>
+          <a:lstStyle/>
+          <a:p>
+            <a:pPr algn="l">
+              <a:lnSpc>
+                <a:spcPct val="100000"/>
+              </a:lnSpc>
+              <a:spcBef>
+                <a:spcPts val="0"/>
+              </a:spcBef>
+              <a:spcAft>
+                <a:spcPts val="0"/>
+              </a:spcAft>
+              <a:buNone/>
+              <a:defRPr lang="ja-JP" sz="2800" b="1">
+                <a:solidFill>
+                  <a:srgbClr val="303437"/>
+                </a:solidFill>
+                <a:latin typeface="Noto Sans"/>
+                <a:ea typeface="Noto Sans CJK JP"/>
+                <a:cs typeface="Noto Sans"/>
+              </a:defRPr>
+            </a:pPr>
+            <a:r>
+              <a:rPr sz="2800" b="1" lang="ja-JP">
+                <a:solidFill>
+                  <a:srgbClr val="303437"/>
+                </a:solidFill>
+                <a:latin typeface="Noto Sans"/>
+                <a:ea typeface="Noto Sans CJK JP"/>
+                <a:cs typeface="Noto Sans"/>
+              </a:rPr>
+              <a:t>検出方式は領域候補を使うかどうかで異なる</a:t>
+            </a:r>
+          </a:p>
+        </p:txBody>
+      </p:sp>
+      <p:sp>
+        <p:nvSpPr>
+          <p:cNvPr id="3" name="Text Placeholder 2"/>
+          <p:cNvSpPr>
+            <a:spLocks noGrp="1"/>
+          </p:cNvSpPr>
+          <p:nvPr>
+            <p:ph type="body" idx="1"/>
+          </p:nvPr>
+        </p:nvSpPr>
+        <p:spPr>
+          <a:xfrm>
+            <a:off x="594360" y="1373852"/>
+            <a:ext cx="7955279" cy="3200400"/>
+          </a:xfrm>
+        </p:spPr>
+        <p:txBody>
+          <a:bodyPr wrap="square" anchor="t" tIns="91440" bIns="91440"/>
+          <a:lstStyle/>
+          <a:p>
+            <a:pPr algn="l" lvl="0" marL="457200" indent="-355600">
+              <a:lnSpc>
+                <a:spcPct val="110000"/>
+              </a:lnSpc>
+              <a:spcBef>
+                <a:spcPts val="0"/>
+              </a:spcBef>
+              <a:spcAft>
+                <a:spcPts val="700"/>
+              </a:spcAft>
+              <a:buSzPct val="63333"/>
+              <a:buFont typeface="Noto Sans CJK JP"/>
+              <a:buChar char="●"/>
+              <a:defRPr lang="ja-JP" sz="2100" b="0">
+                <a:solidFill>
+                  <a:srgbClr val="303437"/>
+                </a:solidFill>
+                <a:latin typeface="Noto Sans"/>
+                <a:ea typeface="Noto Sans CJK JP"/>
+                <a:cs typeface="Noto Sans"/>
+              </a:defRPr>
+            </a:pPr>
+            <a:r>
+              <a:rPr sz="2100" b="0" lang="ja-JP">
+                <a:solidFill>
+                  <a:srgbClr val="303437"/>
+                </a:solidFill>
+                <a:latin typeface="Noto Sans"/>
+                <a:ea typeface="Noto Sans CJK JP"/>
+                <a:cs typeface="Noto Sans"/>
+              </a:rPr>
+              <a:t>Faster R-CNN（2015）は候補領域を作り、その領域についてカテゴリと位置を推定する二段階方式である。</a:t>
+            </a:r>
+          </a:p>
+          <a:p>
+            <a:pPr algn="l" lvl="0" marL="457200" indent="-355600">
+              <a:lnSpc>
+                <a:spcPct val="110000"/>
+              </a:lnSpc>
+              <a:spcBef>
+                <a:spcPts val="0"/>
+              </a:spcBef>
+              <a:spcAft>
+                <a:spcPts val="700"/>
+              </a:spcAft>
+              <a:buSzPct val="63333"/>
+              <a:buFont typeface="Noto Sans CJK JP"/>
+              <a:buChar char="●"/>
+              <a:defRPr lang="ja-JP" sz="2100" b="0">
+                <a:solidFill>
+                  <a:srgbClr val="303437"/>
+                </a:solidFill>
+                <a:latin typeface="Noto Sans"/>
+                <a:ea typeface="Noto Sans CJK JP"/>
+                <a:cs typeface="Noto Sans"/>
+              </a:defRPr>
+            </a:pPr>
+            <a:r>
+              <a:rPr sz="2100" b="0" lang="ja-JP">
+                <a:solidFill>
+                  <a:srgbClr val="303437"/>
+                </a:solidFill>
+                <a:latin typeface="Noto Sans"/>
+                <a:ea typeface="Noto Sans CJK JP"/>
+                <a:cs typeface="Noto Sans"/>
+              </a:rPr>
+              <a:t>RetinaNet（2017）は画像上の多数の位置から直接検出する一段階方式で、学習中の易しい負例の影響を抑える。</a:t>
+            </a:r>
+          </a:p>
+          <a:p>
+            <a:pPr algn="l" lvl="0" marL="457200" indent="-355600">
+              <a:lnSpc>
+                <a:spcPct val="110000"/>
+              </a:lnSpc>
+              <a:spcBef>
+                <a:spcPts val="0"/>
+              </a:spcBef>
+              <a:spcAft>
+                <a:spcPts val="700"/>
+              </a:spcAft>
+              <a:buSzPct val="63333"/>
+              <a:buFont typeface="Noto Sans CJK JP"/>
+              <a:buChar char="●"/>
+              <a:defRPr lang="ja-JP" sz="2100" b="0">
+                <a:solidFill>
+                  <a:srgbClr val="303437"/>
+                </a:solidFill>
+                <a:latin typeface="Noto Sans"/>
+                <a:ea typeface="Noto Sans CJK JP"/>
+                <a:cs typeface="Noto Sans"/>
+              </a:defRPr>
+            </a:pPr>
+            <a:r>
+              <a:rPr sz="2100" b="0" lang="ja-JP">
+                <a:solidFill>
+                  <a:srgbClr val="303437"/>
+                </a:solidFill>
+                <a:latin typeface="Noto Sans"/>
+                <a:ea typeface="Noto Sans CJK JP"/>
+                <a:cs typeface="Noto Sans"/>
+              </a:rPr>
+              <a:t>RT-DETRv2（2024）は、物体間の関係を扱うTransformerを用いた実時間検出器RT-DETR（2023）を改良した。</a:t>
+            </a:r>
+          </a:p>
+        </p:txBody>
+      </p:sp>
+      <p:sp>
+        <p:nvSpPr>
+          <p:cNvPr id="4" name="Title 3"/>
+          <p:cNvSpPr>
+            <a:spLocks noGrp="1"/>
+          </p:cNvSpPr>
+          <p:nvPr>
+            <p:ph type="title" idx="2"/>
+          </p:nvPr>
+        </p:nvSpPr>
+        <p:spPr>
+          <a:xfrm>
+            <a:off x="75895" y="0"/>
+            <a:ext cx="8115300" cy="480060"/>
+          </a:xfrm>
+        </p:spPr>
+        <p:txBody>
+          <a:bodyPr wrap="square" anchor="ctr" lIns="0" rIns="0" tIns="0" bIns="0"/>
+          <a:lstStyle/>
+          <a:p>
+            <a:pPr algn="l">
+              <a:lnSpc>
+                <a:spcPct val="100000"/>
+              </a:lnSpc>
+              <a:spcBef>
+                <a:spcPts val="0"/>
+              </a:spcBef>
+              <a:spcAft>
+                <a:spcPts val="0"/>
+              </a:spcAft>
+              <a:buNone/>
+              <a:defRPr lang="ja-JP" sz="1400" b="1">
+                <a:solidFill>
+                  <a:srgbClr val="FFFEF8"/>
+                </a:solidFill>
+                <a:latin typeface="Noto Sans"/>
+                <a:ea typeface="Noto Sans CJK JP"/>
+                <a:cs typeface="Noto Sans"/>
+              </a:defRPr>
+            </a:pPr>
+            <a:r>
+              <a:rPr lang="ja-JP" sz="1400" b="1">
+                <a:solidFill>
+                  <a:srgbClr val="FFFEF8"/>
+                </a:solidFill>
+                <a:latin typeface="Noto Sans"/>
+                <a:ea typeface="Noto Sans CJK JP"/>
+                <a:cs typeface="Noto Sans"/>
+              </a:rPr>
+              <a:t>3. 物体検出・領域分割の評価とモデル性能</a:t>
+            </a:r>
+          </a:p>
+        </p:txBody>
+      </p:sp>
+      <p:sp>
+        <p:nvSpPr>
+          <p:cNvPr id="5" name="TextBox 4"/>
+          <p:cNvSpPr txBox="1"/>
+          <p:nvPr/>
+        </p:nvSpPr>
+        <p:spPr>
+          <a:xfrm>
+            <a:off x="502920" y="3987799"/>
+            <a:ext cx="8183879" cy="177800"/>
+          </a:xfrm>
+          <a:prstGeom prst="rect">
+            <a:avLst/>
+          </a:prstGeom>
+          <a:noFill/>
+        </p:spPr>
+        <p:txBody>
+          <a:bodyPr wrap="square" lIns="0" rIns="0" tIns="0" bIns="0">
+            <a:spAutoFit/>
+          </a:bodyPr>
+          <a:lstStyle/>
+          <a:p>
+            <a:pPr algn="l">
+              <a:lnSpc>
+                <a:spcPts val="1400"/>
+              </a:lnSpc>
+              <a:spcBef>
+                <a:spcPts val="0"/>
+              </a:spcBef>
+              <a:spcAft>
+                <a:spcPts val="0"/>
+              </a:spcAft>
+            </a:pPr>
+            <a:r>
+              <a:rPr sz="800" b="0" lang="ja-JP">
+                <a:solidFill>
+                  <a:srgbClr val="626669"/>
+                </a:solidFill>
+                <a:latin typeface="Noto Sans"/>
+                <a:ea typeface="Noto Sans CJK JP"/>
+                <a:cs typeface="Noto Sans"/>
+              </a:rPr>
+              <a:t/>
+            </a:r>
+            <a:r>
+              <a:rPr sz="800" lang="ja-JP">
+                <a:solidFill>
+                  <a:srgbClr val="626669"/>
+                </a:solidFill>
+                <a:latin typeface="Noto Sans"/>
+                <a:ea typeface="Noto Sans CJK JP"/>
+                <a:cs typeface="Noto Sans"/>
+              </a:rPr>
+              <a:t>[1] Ren et al. (2015). NeurIPS. Faster R-CNN: Towards Real-Time Object Detection with Region Proposal Networks.</a:t>
+            </a:r>
+          </a:p>
+        </p:txBody>
+      </p:sp>
+      <p:sp>
+        <p:nvSpPr>
+          <p:cNvPr id="6" name="TextBox 5"/>
+          <p:cNvSpPr txBox="1"/>
+          <p:nvPr/>
+        </p:nvSpPr>
+        <p:spPr>
+          <a:xfrm>
+            <a:off x="5928392" y="4006114"/>
+            <a:ext cx="2758407" cy="177800"/>
+          </a:xfrm>
+          <a:prstGeom prst="rect">
+            <a:avLst/>
+          </a:prstGeom>
+          <a:noFill/>
+        </p:spPr>
+        <p:txBody>
+          <a:bodyPr wrap="none" lIns="0" rIns="0" tIns="0" bIns="0">
+            <a:spAutoFit/>
+          </a:bodyPr>
+          <a:lstStyle/>
+          <a:p>
+            <a:pPr algn="l">
+              <a:lnSpc>
+                <a:spcPts val="1400"/>
+              </a:lnSpc>
+              <a:spcBef>
+                <a:spcPts val="0"/>
+              </a:spcBef>
+              <a:spcAft>
+                <a:spcPts val="0"/>
+              </a:spcAft>
+            </a:pPr>
+            <a:r>
+              <a:rPr sz="800" b="0" lang="ja-JP">
+                <a:solidFill>
+                  <a:srgbClr val="626669"/>
+                </a:solidFill>
+                <a:latin typeface="Noto Sans"/>
+                <a:ea typeface="Noto Sans CJK JP"/>
+                <a:cs typeface="Noto Sans"/>
+              </a:rPr>
+              <a:t/>
+            </a:r>
+            <a:r>
+              <a:rPr sz="800" lang="ja-JP">
+                <a:solidFill>
+                  <a:srgbClr val="626669"/>
+                </a:solidFill>
+                <a:latin typeface="Noto Sans"/>
+                <a:ea typeface="Noto Sans CJK JP"/>
+                <a:cs typeface="Noto Sans"/>
+                <a:hlinkClick r:id="rId3"/>
+              </a:rPr>
+              <a:t>https://arxiv.org/abs/1506.01497</a:t>
+            </a:r>
+          </a:p>
+        </p:txBody>
+      </p:sp>
+      <p:sp>
+        <p:nvSpPr>
+          <p:cNvPr id="7" name="TextBox 6"/>
+          <p:cNvSpPr txBox="1"/>
+          <p:nvPr/>
+        </p:nvSpPr>
+        <p:spPr>
+          <a:xfrm>
+            <a:off x="502920" y="4343400"/>
+            <a:ext cx="8183879" cy="177800"/>
+          </a:xfrm>
+          <a:prstGeom prst="rect">
+            <a:avLst/>
+          </a:prstGeom>
+          <a:noFill/>
+        </p:spPr>
+        <p:txBody>
+          <a:bodyPr wrap="square" lIns="0" rIns="0" tIns="0" bIns="0">
+            <a:spAutoFit/>
+          </a:bodyPr>
+          <a:lstStyle/>
+          <a:p>
+            <a:pPr algn="l">
+              <a:lnSpc>
+                <a:spcPts val="1400"/>
+              </a:lnSpc>
+              <a:spcBef>
+                <a:spcPts val="0"/>
+              </a:spcBef>
+              <a:spcAft>
+                <a:spcPts val="0"/>
+              </a:spcAft>
+            </a:pPr>
+            <a:r>
+              <a:rPr sz="800" b="0" lang="ja-JP">
+                <a:solidFill>
+                  <a:srgbClr val="626669"/>
+                </a:solidFill>
+                <a:latin typeface="Noto Sans"/>
+                <a:ea typeface="Noto Sans CJK JP"/>
+                <a:cs typeface="Noto Sans"/>
+              </a:rPr>
+              <a:t/>
+            </a:r>
+            <a:r>
+              <a:rPr sz="800" lang="ja-JP">
+                <a:solidFill>
+                  <a:srgbClr val="626669"/>
+                </a:solidFill>
+                <a:latin typeface="Noto Sans"/>
+                <a:ea typeface="Noto Sans CJK JP"/>
+                <a:cs typeface="Noto Sans"/>
+              </a:rPr>
+              <a:t>[2] Lin et al. (2017). ICCV. Focal Loss for Dense Object Detection.</a:t>
+            </a:r>
+          </a:p>
+        </p:txBody>
+      </p:sp>
+      <p:sp>
+        <p:nvSpPr>
+          <p:cNvPr id="8" name="TextBox 7"/>
+          <p:cNvSpPr txBox="1"/>
+          <p:nvPr/>
+        </p:nvSpPr>
+        <p:spPr>
+          <a:xfrm>
+            <a:off x="3583598" y="4361713"/>
+            <a:ext cx="5103201" cy="177800"/>
+          </a:xfrm>
+          <a:prstGeom prst="rect">
+            <a:avLst/>
+          </a:prstGeom>
+          <a:noFill/>
+        </p:spPr>
+        <p:txBody>
+          <a:bodyPr wrap="none" lIns="0" rIns="0" tIns="0" bIns="0">
+            <a:spAutoFit/>
+          </a:bodyPr>
+          <a:lstStyle/>
+          <a:p>
+            <a:pPr algn="l">
+              <a:lnSpc>
+                <a:spcPts val="1400"/>
+              </a:lnSpc>
+              <a:spcBef>
+                <a:spcPts val="0"/>
+              </a:spcBef>
+              <a:spcAft>
+                <a:spcPts val="0"/>
+              </a:spcAft>
+            </a:pPr>
+            <a:r>
+              <a:rPr sz="800" b="0" lang="ja-JP">
+                <a:solidFill>
+                  <a:srgbClr val="626669"/>
+                </a:solidFill>
+                <a:latin typeface="Noto Sans"/>
+                <a:ea typeface="Noto Sans CJK JP"/>
+                <a:cs typeface="Noto Sans"/>
+              </a:rPr>
+              <a:t/>
+            </a:r>
+            <a:r>
+              <a:rPr sz="800" lang="ja-JP">
+                <a:solidFill>
+                  <a:srgbClr val="626669"/>
+                </a:solidFill>
+                <a:latin typeface="Noto Sans"/>
+                <a:ea typeface="Noto Sans CJK JP"/>
+                <a:cs typeface="Noto Sans"/>
+                <a:hlinkClick r:id="rId4"/>
+              </a:rPr>
+              <a:t>https://arxiv.org/abs/1708.02002</a:t>
+            </a:r>
+          </a:p>
+        </p:txBody>
+      </p:sp>
+      <p:sp>
+        <p:nvSpPr>
+          <p:cNvPr id="9" name="TextBox 8"/>
+          <p:cNvSpPr txBox="1"/>
+          <p:nvPr/>
+        </p:nvSpPr>
+        <p:spPr>
+          <a:xfrm>
+            <a:off x="502920" y="4699000"/>
+            <a:ext cx="8183879" cy="177800"/>
+          </a:xfrm>
+          <a:prstGeom prst="rect">
+            <a:avLst/>
+          </a:prstGeom>
+          <a:noFill/>
+        </p:spPr>
+        <p:txBody>
+          <a:bodyPr wrap="square" lIns="0" rIns="0" tIns="0" bIns="0">
+            <a:spAutoFit/>
+          </a:bodyPr>
+          <a:lstStyle/>
+          <a:p>
+            <a:pPr algn="l">
+              <a:lnSpc>
+                <a:spcPts val="1400"/>
+              </a:lnSpc>
+              <a:spcBef>
+                <a:spcPts val="0"/>
+              </a:spcBef>
+              <a:spcAft>
+                <a:spcPts val="0"/>
+              </a:spcAft>
+            </a:pPr>
+            <a:r>
+              <a:rPr sz="800" b="0" lang="ja-JP">
+                <a:solidFill>
+                  <a:srgbClr val="626669"/>
+                </a:solidFill>
+                <a:latin typeface="Noto Sans"/>
+                <a:ea typeface="Noto Sans CJK JP"/>
+                <a:cs typeface="Noto Sans"/>
+              </a:rPr>
+              <a:t/>
+            </a:r>
+            <a:r>
+              <a:rPr sz="800" lang="ja-JP">
+                <a:solidFill>
+                  <a:srgbClr val="626669"/>
+                </a:solidFill>
+                <a:latin typeface="Noto Sans"/>
+                <a:ea typeface="Noto Sans CJK JP"/>
+                <a:cs typeface="Noto Sans"/>
+              </a:rPr>
+              <a:t>[3] Lv et al. (2024). arXiv:2407.17140. RT-DETRv2: Improved Baseline with Bag-of-Freebies for Real-Time Detection Transformer.</a:t>
+            </a:r>
+          </a:p>
+        </p:txBody>
+      </p:sp>
+      <p:sp>
+        <p:nvSpPr>
+          <p:cNvPr id="10" name="TextBox 9"/>
+          <p:cNvSpPr txBox="1"/>
+          <p:nvPr/>
+        </p:nvSpPr>
+        <p:spPr>
+          <a:xfrm>
+            <a:off x="6558753" y="4717326"/>
+            <a:ext cx="2128046" cy="177800"/>
+          </a:xfrm>
+          <a:prstGeom prst="rect">
+            <a:avLst/>
+          </a:prstGeom>
+          <a:noFill/>
+        </p:spPr>
+        <p:txBody>
+          <a:bodyPr wrap="none" lIns="0" rIns="0" tIns="0" bIns="0">
+            <a:spAutoFit/>
+          </a:bodyPr>
+          <a:lstStyle/>
+          <a:p>
+            <a:pPr algn="l">
+              <a:lnSpc>
+                <a:spcPts val="1400"/>
+              </a:lnSpc>
+              <a:spcBef>
+                <a:spcPts val="0"/>
+              </a:spcBef>
+              <a:spcAft>
+                <a:spcPts val="0"/>
+              </a:spcAft>
+            </a:pPr>
+            <a:r>
+              <a:rPr sz="800" b="0" lang="ja-JP">
+                <a:solidFill>
+                  <a:srgbClr val="626669"/>
+                </a:solidFill>
+                <a:latin typeface="Noto Sans"/>
+                <a:ea typeface="Noto Sans CJK JP"/>
+                <a:cs typeface="Noto Sans"/>
+              </a:rPr>
+              <a:t/>
+            </a:r>
+            <a:r>
+              <a:rPr sz="800" lang="ja-JP">
+                <a:solidFill>
+                  <a:srgbClr val="626669"/>
+                </a:solidFill>
+                <a:latin typeface="Noto Sans"/>
+                <a:ea typeface="Noto Sans CJK JP"/>
+                <a:cs typeface="Noto Sans"/>
+                <a:hlinkClick r:id="rId2"/>
+              </a:rPr>
+              <a:t>https://arxiv.org/abs/2407.17140</a:t>
+            </a:r>
+          </a:p>
+        </p:txBody>
+      </p:sp>
+    </p:spTree>
+  </p:cSld>
+  <p:clrMapOvr>
+    <a:masterClrMapping/>
+  </p:clrMapOvr>
+</p:sld>
+</file>
+
+<file path=ppt/slides/slide44.xml><?xml version="1.0" encoding="utf-8"?>
+<p:sld xmlns:a="http://schemas.openxmlformats.org/drawingml/2006/main" xmlns:p="http://schemas.openxmlformats.org/presentationml/2006/main" xmlns:r="http://schemas.openxmlformats.org/officeDocument/2006/relationships">
+  <p:cSld>
+    <p:spTree>
+      <p:nvGrpSpPr>
+        <p:cNvPr id="1" name=""/>
+        <p:cNvGrpSpPr/>
+        <p:nvPr/>
+      </p:nvGrpSpPr>
+      <p:grpSpPr/>
+      <p:sp>
+        <p:nvSpPr>
+          <p:cNvPr id="2" name="Title 1"/>
+          <p:cNvSpPr>
+            <a:spLocks noGrp="1"/>
+          </p:cNvSpPr>
+          <p:nvPr>
+            <p:ph type="title"/>
+          </p:nvPr>
+        </p:nvSpPr>
+        <p:spPr>
+          <a:xfrm>
+            <a:off x="468172" y="650138"/>
+            <a:ext cx="8206740" cy="616305"/>
+          </a:xfrm>
+        </p:spPr>
+        <p:txBody>
+          <a:bodyPr wrap="none" anchor="t" lIns="0" rIns="0" tIns="0" bIns="0"/>
+          <a:lstStyle/>
+          <a:p>
+            <a:pPr algn="l">
+              <a:lnSpc>
+                <a:spcPct val="100000"/>
+              </a:lnSpc>
+              <a:spcBef>
+                <a:spcPts val="0"/>
+              </a:spcBef>
+              <a:spcAft>
+                <a:spcPts val="0"/>
+              </a:spcAft>
+              <a:buNone/>
+              <a:defRPr lang="ja-JP" sz="2800" b="1">
+                <a:solidFill>
+                  <a:srgbClr val="303437"/>
+                </a:solidFill>
+                <a:latin typeface="Noto Sans"/>
+                <a:ea typeface="Noto Sans CJK JP"/>
+                <a:cs typeface="Noto Sans"/>
+              </a:defRPr>
+            </a:pPr>
+            <a:r>
+              <a:rPr sz="2800" b="1" lang="ja-JP">
+                <a:solidFill>
+                  <a:srgbClr val="303437"/>
+                </a:solidFill>
+                <a:latin typeface="Noto Sans"/>
+                <a:ea typeface="Noto Sans CJK JP"/>
+                <a:cs typeface="Noto Sans"/>
+              </a:rPr>
+              <a:t>R50・FPN・3xはモデルと学習設定を表す</a:t>
+            </a:r>
+          </a:p>
+        </p:txBody>
+      </p:sp>
+      <p:sp>
+        <p:nvSpPr>
+          <p:cNvPr id="3" name="Text Placeholder 2"/>
+          <p:cNvSpPr>
+            <a:spLocks noGrp="1"/>
+          </p:cNvSpPr>
+          <p:nvPr>
+            <p:ph type="body" idx="1"/>
+          </p:nvPr>
+        </p:nvSpPr>
+        <p:spPr>
+          <a:xfrm>
+            <a:off x="594360" y="1301097"/>
+            <a:ext cx="7955279" cy="3200400"/>
+          </a:xfrm>
+        </p:spPr>
+        <p:txBody>
+          <a:bodyPr wrap="square" anchor="t" tIns="91440" bIns="91440"/>
+          <a:lstStyle/>
+          <a:p>
+            <a:pPr algn="l" lvl="0" marL="457200" indent="-355600">
+              <a:lnSpc>
+                <a:spcPct val="115000"/>
+              </a:lnSpc>
+              <a:spcBef>
+                <a:spcPts val="0"/>
+              </a:spcBef>
+              <a:spcAft>
+                <a:spcPts val="1000"/>
+              </a:spcAft>
+              <a:buSzPct val="57826"/>
+              <a:buFont typeface="Noto Sans CJK JP"/>
+              <a:buChar char="●"/>
+              <a:defRPr lang="ja-JP" sz="2300" b="0">
+                <a:solidFill>
+                  <a:srgbClr val="303437"/>
+                </a:solidFill>
+                <a:latin typeface="Noto Sans"/>
+                <a:ea typeface="Noto Sans CJK JP"/>
+                <a:cs typeface="Noto Sans"/>
+              </a:defRPr>
+            </a:pPr>
+            <a:r>
+              <a:rPr sz="2300" b="0" lang="ja-JP">
+                <a:solidFill>
+                  <a:srgbClr val="303437"/>
+                </a:solidFill>
+                <a:latin typeface="Noto Sans"/>
+                <a:ea typeface="Noto Sans CJK JP"/>
+                <a:cs typeface="Noto Sans"/>
+              </a:rPr>
+              <a:t>R50は、画像から特徴を抽出する50層のResNet-50（2016）を指す。</a:t>
+            </a:r>
+          </a:p>
+          <a:p>
+            <a:pPr algn="l" lvl="0" marL="457200" indent="-355600">
+              <a:lnSpc>
+                <a:spcPct val="115000"/>
+              </a:lnSpc>
+              <a:spcBef>
+                <a:spcPts val="0"/>
+              </a:spcBef>
+              <a:spcAft>
+                <a:spcPts val="1000"/>
+              </a:spcAft>
+              <a:buSzPct val="57826"/>
+              <a:buFont typeface="Noto Sans CJK JP"/>
+              <a:buChar char="●"/>
+              <a:defRPr lang="ja-JP" sz="2300" b="0">
+                <a:solidFill>
+                  <a:srgbClr val="303437"/>
+                </a:solidFill>
+                <a:latin typeface="Noto Sans"/>
+                <a:ea typeface="Noto Sans CJK JP"/>
+                <a:cs typeface="Noto Sans"/>
+              </a:defRPr>
+            </a:pPr>
+            <a:r>
+              <a:rPr sz="2300" b="0" lang="ja-JP">
+                <a:solidFill>
+                  <a:srgbClr val="303437"/>
+                </a:solidFill>
+                <a:latin typeface="Noto Sans"/>
+                <a:ea typeface="Noto Sans CJK JP"/>
+                <a:cs typeface="Noto Sans"/>
+              </a:rPr>
+              <a:t>FPNは、異なる解像度の特徴を統合するFeature Pyramid Networks（2017）を指す。</a:t>
+            </a:r>
+          </a:p>
+          <a:p>
+            <a:pPr algn="l" lvl="0" marL="457200" indent="-355600">
+              <a:lnSpc>
+                <a:spcPct val="115000"/>
+              </a:lnSpc>
+              <a:spcBef>
+                <a:spcPts val="0"/>
+              </a:spcBef>
+              <a:spcAft>
+                <a:spcPts val="1000"/>
+              </a:spcAft>
+              <a:buSzPct val="57826"/>
+              <a:buFont typeface="Noto Sans CJK JP"/>
+              <a:buChar char="●"/>
+              <a:defRPr lang="ja-JP" sz="2300" b="0">
+                <a:solidFill>
+                  <a:srgbClr val="303437"/>
+                </a:solidFill>
+                <a:latin typeface="Noto Sans"/>
+                <a:ea typeface="Noto Sans CJK JP"/>
+                <a:cs typeface="Noto Sans"/>
+              </a:defRPr>
+            </a:pPr>
+            <a:r>
+              <a:rPr sz="2300" b="0" lang="ja-JP">
+                <a:solidFill>
+                  <a:srgbClr val="303437"/>
+                </a:solidFill>
+                <a:latin typeface="Noto Sans"/>
+                <a:ea typeface="Noto Sans CJK JP"/>
+                <a:cs typeface="Noto Sans"/>
+              </a:rPr>
+              <a:t>3xは公開実装の学習スケジュール名で、標準的な1xより長く学習する設定を示す。</a:t>
+            </a:r>
+          </a:p>
+        </p:txBody>
+      </p:sp>
+      <p:sp>
+        <p:nvSpPr>
+          <p:cNvPr id="4" name="Title 3"/>
+          <p:cNvSpPr>
+            <a:spLocks noGrp="1"/>
+          </p:cNvSpPr>
+          <p:nvPr>
+            <p:ph type="title" idx="2"/>
+          </p:nvPr>
+        </p:nvSpPr>
+        <p:spPr>
+          <a:xfrm>
+            <a:off x="75895" y="0"/>
+            <a:ext cx="8115300" cy="480060"/>
+          </a:xfrm>
+        </p:spPr>
+        <p:txBody>
+          <a:bodyPr wrap="square" anchor="ctr" lIns="0" rIns="0" tIns="0" bIns="0"/>
+          <a:lstStyle/>
+          <a:p>
+            <a:pPr algn="l">
+              <a:lnSpc>
+                <a:spcPct val="100000"/>
+              </a:lnSpc>
+              <a:spcBef>
+                <a:spcPts val="0"/>
+              </a:spcBef>
+              <a:spcAft>
+                <a:spcPts val="0"/>
+              </a:spcAft>
+              <a:buNone/>
+              <a:defRPr lang="ja-JP" sz="1400" b="1">
+                <a:solidFill>
+                  <a:srgbClr val="FFFEF8"/>
+                </a:solidFill>
+                <a:latin typeface="Noto Sans"/>
+                <a:ea typeface="Noto Sans CJK JP"/>
+                <a:cs typeface="Noto Sans"/>
+              </a:defRPr>
+            </a:pPr>
+            <a:r>
+              <a:rPr lang="ja-JP" sz="1400" b="1">
+                <a:solidFill>
+                  <a:srgbClr val="FFFEF8"/>
+                </a:solidFill>
+                <a:latin typeface="Noto Sans"/>
+                <a:ea typeface="Noto Sans CJK JP"/>
+                <a:cs typeface="Noto Sans"/>
+              </a:rPr>
+              <a:t>3. 物体検出・領域分割の評価とモデル性能</a:t>
+            </a:r>
+          </a:p>
+        </p:txBody>
+      </p:sp>
+      <p:sp>
+        <p:nvSpPr>
+          <p:cNvPr id="5" name="TextBox 4"/>
+          <p:cNvSpPr txBox="1"/>
+          <p:nvPr/>
+        </p:nvSpPr>
+        <p:spPr>
+          <a:xfrm>
+            <a:off x="502920" y="4165600"/>
+            <a:ext cx="8183879" cy="177800"/>
+          </a:xfrm>
+          <a:prstGeom prst="rect">
+            <a:avLst/>
+          </a:prstGeom>
+          <a:noFill/>
+        </p:spPr>
+        <p:txBody>
+          <a:bodyPr wrap="square" lIns="0" rIns="0" tIns="0" bIns="0">
+            <a:spAutoFit/>
+          </a:bodyPr>
+          <a:lstStyle/>
+          <a:p>
+            <a:pPr algn="l">
+              <a:lnSpc>
+                <a:spcPts val="1400"/>
+              </a:lnSpc>
+              <a:spcBef>
+                <a:spcPts val="0"/>
+              </a:spcBef>
+              <a:spcAft>
+                <a:spcPts val="0"/>
+              </a:spcAft>
+            </a:pPr>
+            <a:r>
+              <a:rPr sz="800" b="0" lang="ja-JP">
+                <a:solidFill>
+                  <a:srgbClr val="626669"/>
+                </a:solidFill>
+                <a:latin typeface="Noto Sans"/>
+                <a:ea typeface="Noto Sans CJK JP"/>
+                <a:cs typeface="Noto Sans"/>
+              </a:rPr>
+              <a:t/>
+            </a:r>
+            <a:r>
+              <a:rPr sz="800" lang="ja-JP">
+                <a:solidFill>
+                  <a:srgbClr val="626669"/>
+                </a:solidFill>
+                <a:latin typeface="Noto Sans"/>
+                <a:ea typeface="Noto Sans CJK JP"/>
+                <a:cs typeface="Noto Sans"/>
+              </a:rPr>
+              <a:t>[1] He et al. (2016). CVPR, pp. 770–778. Deep Residual Learning for Image Recognition.</a:t>
+            </a:r>
+          </a:p>
+        </p:txBody>
+      </p:sp>
+      <p:sp>
+        <p:nvSpPr>
+          <p:cNvPr id="6" name="TextBox 5"/>
+          <p:cNvSpPr txBox="1"/>
+          <p:nvPr/>
+        </p:nvSpPr>
+        <p:spPr>
+          <a:xfrm>
+            <a:off x="4664725" y="4183913"/>
+            <a:ext cx="4022074" cy="177800"/>
+          </a:xfrm>
+          <a:prstGeom prst="rect">
+            <a:avLst/>
+          </a:prstGeom>
+          <a:noFill/>
+        </p:spPr>
+        <p:txBody>
+          <a:bodyPr wrap="none" lIns="0" rIns="0" tIns="0" bIns="0">
+            <a:spAutoFit/>
+          </a:bodyPr>
+          <a:lstStyle/>
+          <a:p>
+            <a:pPr algn="l">
+              <a:lnSpc>
+                <a:spcPts val="1400"/>
+              </a:lnSpc>
+              <a:spcBef>
+                <a:spcPts val="0"/>
+              </a:spcBef>
+              <a:spcAft>
+                <a:spcPts val="0"/>
+              </a:spcAft>
+            </a:pPr>
+            <a:r>
+              <a:rPr sz="800" b="0" lang="ja-JP">
+                <a:solidFill>
+                  <a:srgbClr val="626669"/>
+                </a:solidFill>
+                <a:latin typeface="Noto Sans"/>
+                <a:ea typeface="Noto Sans CJK JP"/>
+                <a:cs typeface="Noto Sans"/>
+              </a:rPr>
+              <a:t/>
+            </a:r>
+            <a:r>
+              <a:rPr sz="800" lang="ja-JP">
+                <a:solidFill>
+                  <a:srgbClr val="626669"/>
+                </a:solidFill>
+                <a:latin typeface="Noto Sans"/>
+                <a:ea typeface="Noto Sans CJK JP"/>
+                <a:cs typeface="Noto Sans"/>
+                <a:hlinkClick r:id="rId3"/>
+              </a:rPr>
+              <a:t>https://arxiv.org/abs/1512.03385</a:t>
+            </a:r>
+          </a:p>
+        </p:txBody>
+      </p:sp>
+      <p:sp>
+        <p:nvSpPr>
+          <p:cNvPr id="7" name="TextBox 6"/>
+          <p:cNvSpPr txBox="1"/>
+          <p:nvPr/>
+        </p:nvSpPr>
+        <p:spPr>
+          <a:xfrm>
+            <a:off x="502920" y="4521200"/>
+            <a:ext cx="8183879" cy="177800"/>
+          </a:xfrm>
+          <a:prstGeom prst="rect">
+            <a:avLst/>
+          </a:prstGeom>
+          <a:noFill/>
+        </p:spPr>
+        <p:txBody>
+          <a:bodyPr wrap="square" lIns="0" rIns="0" tIns="0" bIns="0">
+            <a:spAutoFit/>
+          </a:bodyPr>
+          <a:lstStyle/>
+          <a:p>
+            <a:pPr algn="l">
+              <a:lnSpc>
+                <a:spcPts val="1400"/>
+              </a:lnSpc>
+              <a:spcBef>
+                <a:spcPts val="0"/>
+              </a:spcBef>
+              <a:spcAft>
+                <a:spcPts val="0"/>
+              </a:spcAft>
+            </a:pPr>
+            <a:r>
+              <a:rPr sz="800" b="0" lang="ja-JP">
+                <a:solidFill>
+                  <a:srgbClr val="626669"/>
+                </a:solidFill>
+                <a:latin typeface="Noto Sans"/>
+                <a:ea typeface="Noto Sans CJK JP"/>
+                <a:cs typeface="Noto Sans"/>
+              </a:rPr>
+              <a:t/>
+            </a:r>
+            <a:r>
+              <a:rPr sz="800" lang="ja-JP">
+                <a:solidFill>
+                  <a:srgbClr val="626669"/>
+                </a:solidFill>
+                <a:latin typeface="Noto Sans"/>
+                <a:ea typeface="Noto Sans CJK JP"/>
+                <a:cs typeface="Noto Sans"/>
+              </a:rPr>
+              <a:t>[2] Lin et al. (2017). CVPR. Feature Pyramid Networks for Object Detection.</a:t>
+            </a:r>
+          </a:p>
+        </p:txBody>
+      </p:sp>
+      <p:sp>
+        <p:nvSpPr>
+          <p:cNvPr id="8" name="TextBox 7"/>
+          <p:cNvSpPr txBox="1"/>
+          <p:nvPr/>
+        </p:nvSpPr>
+        <p:spPr>
+          <a:xfrm>
+            <a:off x="4074365" y="4539526"/>
+            <a:ext cx="4612434" cy="177800"/>
+          </a:xfrm>
+          <a:prstGeom prst="rect">
+            <a:avLst/>
+          </a:prstGeom>
+          <a:noFill/>
+        </p:spPr>
+        <p:txBody>
+          <a:bodyPr wrap="none" lIns="0" rIns="0" tIns="0" bIns="0">
+            <a:spAutoFit/>
+          </a:bodyPr>
+          <a:lstStyle/>
+          <a:p>
+            <a:pPr algn="l">
+              <a:lnSpc>
+                <a:spcPts val="1400"/>
+              </a:lnSpc>
+              <a:spcBef>
+                <a:spcPts val="0"/>
+              </a:spcBef>
+              <a:spcAft>
+                <a:spcPts val="0"/>
+              </a:spcAft>
+            </a:pPr>
+            <a:r>
+              <a:rPr sz="800" b="0" lang="ja-JP">
+                <a:solidFill>
+                  <a:srgbClr val="626669"/>
+                </a:solidFill>
+                <a:latin typeface="Noto Sans"/>
+                <a:ea typeface="Noto Sans CJK JP"/>
+                <a:cs typeface="Noto Sans"/>
+              </a:rPr>
+              <a:t/>
+            </a:r>
+            <a:r>
+              <a:rPr sz="800" lang="ja-JP">
+                <a:solidFill>
+                  <a:srgbClr val="626669"/>
+                </a:solidFill>
+                <a:latin typeface="Noto Sans"/>
+                <a:ea typeface="Noto Sans CJK JP"/>
+                <a:cs typeface="Noto Sans"/>
+                <a:hlinkClick r:id="rId4"/>
+              </a:rPr>
+              <a:t>https://arxiv.org/abs/1612.03144</a:t>
+            </a:r>
+          </a:p>
+        </p:txBody>
+      </p:sp>
+      <p:sp>
+        <p:nvSpPr>
+          <p:cNvPr id="9" name="TextBox 8"/>
+          <p:cNvSpPr txBox="1"/>
+          <p:nvPr/>
+        </p:nvSpPr>
+        <p:spPr>
+          <a:xfrm>
+            <a:off x="502920" y="4876800"/>
+            <a:ext cx="8183879" cy="177800"/>
+          </a:xfrm>
+          <a:prstGeom prst="rect">
+            <a:avLst/>
+          </a:prstGeom>
+          <a:noFill/>
+        </p:spPr>
+        <p:txBody>
+          <a:bodyPr wrap="square" lIns="0" rIns="0" tIns="0" bIns="0">
+            <a:spAutoFit/>
+          </a:bodyPr>
+          <a:lstStyle/>
+          <a:p>
+            <a:pPr algn="l">
+              <a:lnSpc>
+                <a:spcPts val="1400"/>
+              </a:lnSpc>
+              <a:spcBef>
+                <a:spcPts val="0"/>
+              </a:spcBef>
+              <a:spcAft>
+                <a:spcPts val="0"/>
+              </a:spcAft>
+            </a:pPr>
+            <a:r>
+              <a:rPr sz="800" b="0" lang="ja-JP">
+                <a:solidFill>
+                  <a:srgbClr val="626669"/>
+                </a:solidFill>
+                <a:latin typeface="Noto Sans"/>
+                <a:ea typeface="Noto Sans CJK JP"/>
+                <a:cs typeface="Noto Sans"/>
+              </a:rPr>
+              <a:t/>
+            </a:r>
+            <a:r>
+              <a:rPr sz="800" lang="ja-JP">
+                <a:solidFill>
+                  <a:srgbClr val="626669"/>
+                </a:solidFill>
+                <a:latin typeface="Noto Sans"/>
+                <a:ea typeface="Noto Sans CJK JP"/>
+                <a:cs typeface="Noto Sans"/>
+              </a:rPr>
+              <a:t>[3] </a:t>
+            </a:r>
+            <a:r>
+              <a:rPr sz="800" lang="ja-JP">
+                <a:solidFill>
+                  <a:srgbClr val="626669"/>
+                </a:solidFill>
+                <a:latin typeface="Noto Sans"/>
+                <a:ea typeface="Noto Sans CJK JP"/>
+                <a:cs typeface="Noto Sans"/>
+                <a:hlinkClick r:id="rId2"/>
+              </a:rPr>
+              <a:t>https://github.com/facebookresearch/detectron2/blob/main/MODEL_ZOO.md</a:t>
+            </a:r>
+          </a:p>
+        </p:txBody>
+      </p:sp>
+    </p:spTree>
+  </p:cSld>
+  <p:clrMapOvr>
+    <a:masterClrMapping/>
+  </p:clrMapOvr>
+</p:sld>
+</file>
+
 <file path=ppt/slides/slide45.xml><?xml version="1.0" encoding="utf-8"?>
 <p:sld xmlns:a="http://schemas.openxmlformats.org/drawingml/2006/main" xmlns:p="http://schemas.openxmlformats.org/presentationml/2006/main" xmlns:r="http://schemas.openxmlformats.org/officeDocument/2006/relationships">
   <p:cSld>
@@ -29422,375 +29321,6 @@
 </p:sld>
 </file>
 
-<file path=ppt/slides/slide47.xml><?xml version="1.0" encoding="utf-8"?>
-<p:sld xmlns:a="http://schemas.openxmlformats.org/drawingml/2006/main" xmlns:p="http://schemas.openxmlformats.org/presentationml/2006/main" xmlns:r="http://schemas.openxmlformats.org/officeDocument/2006/relationships">
-  <p:cSld>
-    <p:spTree>
-      <p:nvGrpSpPr>
-        <p:cNvPr id="1" name=""/>
-        <p:cNvGrpSpPr/>
-        <p:nvPr/>
-      </p:nvGrpSpPr>
-      <p:grpSpPr/>
-      <p:sp>
-        <p:nvSpPr>
-          <p:cNvPr id="2" name="Title 1"/>
-          <p:cNvSpPr>
-            <a:spLocks noGrp="1"/>
-          </p:cNvSpPr>
-          <p:nvPr>
-            <p:ph type="title"/>
-          </p:nvPr>
-        </p:nvSpPr>
-        <p:spPr>
-          <a:xfrm>
-            <a:off x="468172" y="650138"/>
-            <a:ext cx="8206740" cy="616305"/>
-          </a:xfrm>
-        </p:spPr>
-        <p:txBody>
-          <a:bodyPr wrap="none" anchor="t" lIns="0" rIns="0" tIns="0" bIns="0"/>
-          <a:lstStyle/>
-          <a:p>
-            <a:pPr algn="l">
-              <a:lnSpc>
-                <a:spcPct val="100000"/>
-              </a:lnSpc>
-              <a:spcBef>
-                <a:spcPts val="0"/>
-              </a:spcBef>
-              <a:spcAft>
-                <a:spcPts val="0"/>
-              </a:spcAft>
-              <a:buNone/>
-              <a:defRPr lang="ja-JP" sz="2800" b="1">
-                <a:solidFill>
-                  <a:srgbClr val="303437"/>
-                </a:solidFill>
-                <a:latin typeface="Noto Sans"/>
-                <a:ea typeface="Noto Sans CJK JP"/>
-                <a:cs typeface="Noto Sans"/>
-              </a:defRPr>
-            </a:pPr>
-            <a:r>
-              <a:rPr sz="2800" b="1" lang="ja-JP">
-                <a:solidFill>
-                  <a:srgbClr val="303437"/>
-                </a:solidFill>
-                <a:latin typeface="Noto Sans"/>
-                <a:ea typeface="Noto Sans CJK JP"/>
-                <a:cs typeface="Noto Sans"/>
-              </a:rPr>
-              <a:t>COCOの評価対象と汎化の範囲</a:t>
-            </a:r>
-          </a:p>
-        </p:txBody>
-      </p:sp>
-      <p:sp>
-        <p:nvSpPr>
-          <p:cNvPr id="3" name="Text Placeholder 2"/>
-          <p:cNvSpPr>
-            <a:spLocks noGrp="1"/>
-          </p:cNvSpPr>
-          <p:nvPr>
-            <p:ph type="body" idx="1"/>
-          </p:nvPr>
-        </p:nvSpPr>
-        <p:spPr>
-          <a:xfrm>
-            <a:off x="594360" y="1417320"/>
-            <a:ext cx="7955279" cy="3200400"/>
-          </a:xfrm>
-        </p:spPr>
-        <p:txBody>
-          <a:bodyPr wrap="square" anchor="t" tIns="91440" bIns="91440"/>
-          <a:lstStyle/>
-          <a:p>
-            <a:pPr algn="l" lvl="0" marL="457200" indent="-355600">
-              <a:lnSpc>
-                <a:spcPct val="115000"/>
-              </a:lnSpc>
-              <a:spcBef>
-                <a:spcPts val="0"/>
-              </a:spcBef>
-              <a:spcAft>
-                <a:spcPts val="1000"/>
-              </a:spcAft>
-              <a:buSzPct val="57826"/>
-              <a:buFont typeface="Noto Sans CJK JP"/>
-              <a:buChar char="●"/>
-              <a:defRPr lang="ja-JP" sz="2300" b="0">
-                <a:solidFill>
-                  <a:srgbClr val="303437"/>
-                </a:solidFill>
-                <a:latin typeface="Noto Sans"/>
-                <a:ea typeface="Noto Sans CJK JP"/>
-                <a:cs typeface="Noto Sans"/>
-              </a:defRPr>
-            </a:pPr>
-            <a:r>
-              <a:rPr sz="2300" b="0" lang="ja-JP">
-                <a:solidFill>
-                  <a:srgbClr val="303437"/>
-                </a:solidFill>
-                <a:latin typeface="Noto Sans"/>
-                <a:ea typeface="Noto Sans CJK JP"/>
-                <a:cs typeface="Noto Sans"/>
-              </a:rPr>
-              <a:t>COCOの物体検出は80カテゴリを対象とし、未知カテゴリや専門分野の物体認識を直接は測らない。</a:t>
-            </a:r>
-          </a:p>
-          <a:p>
-            <a:pPr algn="l" lvl="0" marL="457200" indent="-355600">
-              <a:lnSpc>
-                <a:spcPct val="115000"/>
-              </a:lnSpc>
-              <a:spcBef>
-                <a:spcPts val="0"/>
-              </a:spcBef>
-              <a:spcAft>
-                <a:spcPts val="1000"/>
-              </a:spcAft>
-              <a:buSzPct val="57826"/>
-              <a:buFont typeface="Noto Sans CJK JP"/>
-              <a:buChar char="●"/>
-              <a:defRPr lang="ja-JP" sz="2300" b="0">
-                <a:solidFill>
-                  <a:srgbClr val="303437"/>
-                </a:solidFill>
-                <a:latin typeface="Noto Sans"/>
-                <a:ea typeface="Noto Sans CJK JP"/>
-                <a:cs typeface="Noto Sans"/>
-              </a:defRPr>
-            </a:pPr>
-            <a:r>
-              <a:rPr sz="2300" b="0" lang="ja-JP">
-                <a:solidFill>
-                  <a:srgbClr val="303437"/>
-                </a:solidFill>
-                <a:latin typeface="Noto Sans"/>
-                <a:ea typeface="Noto Sans CJK JP"/>
-                <a:cs typeface="Noto Sans"/>
-              </a:rPr>
-              <a:t>小さな物体・混雑・遮蔽に加え、注釈の範囲や不確実性も得点の解釈に関わる。</a:t>
-            </a:r>
-          </a:p>
-          <a:p>
-            <a:pPr algn="l" lvl="0" marL="457200" indent="-355600">
-              <a:lnSpc>
-                <a:spcPct val="115000"/>
-              </a:lnSpc>
-              <a:spcBef>
-                <a:spcPts val="0"/>
-              </a:spcBef>
-              <a:spcAft>
-                <a:spcPts val="1000"/>
-              </a:spcAft>
-              <a:buSzPct val="57826"/>
-              <a:buFont typeface="Noto Sans CJK JP"/>
-              <a:buChar char="●"/>
-              <a:defRPr lang="ja-JP" sz="2300" b="0">
-                <a:solidFill>
-                  <a:srgbClr val="303437"/>
-                </a:solidFill>
-                <a:latin typeface="Noto Sans"/>
-                <a:ea typeface="Noto Sans CJK JP"/>
-                <a:cs typeface="Noto Sans"/>
-              </a:defRPr>
-            </a:pPr>
-            <a:r>
-              <a:rPr sz="2300" b="0" lang="ja-JP">
-                <a:solidFill>
-                  <a:srgbClr val="303437"/>
-                </a:solidFill>
-                <a:latin typeface="Noto Sans"/>
-                <a:ea typeface="Noto Sans CJK JP"/>
-                <a:cs typeface="Noto Sans"/>
-              </a:rPr>
-              <a:t>手法の比較では、発表年だけでなく学習画像・事前学習・入力サイズ・評価集合を確認する必要がある。</a:t>
-            </a:r>
-          </a:p>
-        </p:txBody>
-      </p:sp>
-      <p:sp>
-        <p:nvSpPr>
-          <p:cNvPr id="4" name="Title 3"/>
-          <p:cNvSpPr>
-            <a:spLocks noGrp="1"/>
-          </p:cNvSpPr>
-          <p:nvPr>
-            <p:ph type="title" idx="2"/>
-          </p:nvPr>
-        </p:nvSpPr>
-        <p:spPr>
-          <a:xfrm>
-            <a:off x="75895" y="0"/>
-            <a:ext cx="8115300" cy="480060"/>
-          </a:xfrm>
-        </p:spPr>
-        <p:txBody>
-          <a:bodyPr wrap="square" anchor="ctr" lIns="0" rIns="0" tIns="0" bIns="0"/>
-          <a:lstStyle/>
-          <a:p>
-            <a:pPr algn="l">
-              <a:lnSpc>
-                <a:spcPct val="100000"/>
-              </a:lnSpc>
-              <a:spcBef>
-                <a:spcPts val="0"/>
-              </a:spcBef>
-              <a:spcAft>
-                <a:spcPts val="0"/>
-              </a:spcAft>
-              <a:buNone/>
-              <a:defRPr lang="ja-JP" sz="1400" b="1">
-                <a:solidFill>
-                  <a:srgbClr val="FFFEF8"/>
-                </a:solidFill>
-                <a:latin typeface="Noto Sans"/>
-                <a:ea typeface="Noto Sans CJK JP"/>
-                <a:cs typeface="Noto Sans"/>
-              </a:defRPr>
-            </a:pPr>
-            <a:r>
-              <a:rPr lang="ja-JP" sz="1400" b="1">
-                <a:solidFill>
-                  <a:srgbClr val="FFFEF8"/>
-                </a:solidFill>
-                <a:latin typeface="Noto Sans"/>
-                <a:ea typeface="Noto Sans CJK JP"/>
-                <a:cs typeface="Noto Sans"/>
-              </a:rPr>
-              <a:t>3. 物体検出・領域分割の評価とモデル性能</a:t>
-            </a:r>
-          </a:p>
-        </p:txBody>
-      </p:sp>
-      <p:sp>
-        <p:nvSpPr>
-          <p:cNvPr id="5" name="TextBox 4"/>
-          <p:cNvSpPr txBox="1"/>
-          <p:nvPr/>
-        </p:nvSpPr>
-        <p:spPr>
-          <a:xfrm>
-            <a:off x="502920" y="4521200"/>
-            <a:ext cx="8183879" cy="355600"/>
-          </a:xfrm>
-          <a:prstGeom prst="rect">
-            <a:avLst/>
-          </a:prstGeom>
-          <a:noFill/>
-        </p:spPr>
-        <p:txBody>
-          <a:bodyPr wrap="square" lIns="0" rIns="0" tIns="0" bIns="0">
-            <a:spAutoFit/>
-          </a:bodyPr>
-          <a:lstStyle/>
-          <a:p>
-            <a:pPr algn="l">
-              <a:lnSpc>
-                <a:spcPts val="1400"/>
-              </a:lnSpc>
-              <a:spcBef>
-                <a:spcPts val="0"/>
-              </a:spcBef>
-              <a:spcAft>
-                <a:spcPts val="0"/>
-              </a:spcAft>
-            </a:pPr>
-            <a:r>
-              <a:rPr sz="800" b="0" lang="ja-JP">
-                <a:solidFill>
-                  <a:srgbClr val="626669"/>
-                </a:solidFill>
-                <a:latin typeface="Noto Sans"/>
-                <a:ea typeface="Noto Sans CJK JP"/>
-                <a:cs typeface="Noto Sans"/>
-              </a:rPr>
-              <a:t/>
-            </a:r>
-            <a:r>
-              <a:rPr sz="800" lang="ja-JP">
-                <a:solidFill>
-                  <a:srgbClr val="626669"/>
-                </a:solidFill>
-                <a:latin typeface="Noto Sans"/>
-                <a:ea typeface="Noto Sans CJK JP"/>
-                <a:cs typeface="Noto Sans"/>
-              </a:rPr>
-              <a:t>[1] Agrim Gupta et al. (2019). IEEE/CVF Conference on Computer Vision and Pattern Recognition (CVPR), pp. 5356–5364. LVIS: A Dataset for Large Vocabulary Instance Segmentation.</a:t>
-            </a:r>
-          </a:p>
-        </p:txBody>
-      </p:sp>
-      <p:sp>
-        <p:nvSpPr>
-          <p:cNvPr id="6" name="TextBox 5"/>
-          <p:cNvSpPr txBox="1"/>
-          <p:nvPr/>
-        </p:nvSpPr>
-        <p:spPr>
-          <a:xfrm>
-            <a:off x="1254031" y="4717326"/>
-            <a:ext cx="7432768" cy="177800"/>
-          </a:xfrm>
-          <a:prstGeom prst="rect">
-            <a:avLst/>
-          </a:prstGeom>
-          <a:noFill/>
-        </p:spPr>
-        <p:txBody>
-          <a:bodyPr wrap="none" lIns="0" rIns="0" tIns="0" bIns="0">
-            <a:spAutoFit/>
-          </a:bodyPr>
-          <a:lstStyle/>
-          <a:p>
-            <a:pPr algn="l">
-              <a:lnSpc>
-                <a:spcPts val="1400"/>
-              </a:lnSpc>
-              <a:spcBef>
-                <a:spcPts val="0"/>
-              </a:spcBef>
-              <a:spcAft>
-                <a:spcPts val="0"/>
-              </a:spcAft>
-            </a:pPr>
-            <a:r>
-              <a:rPr sz="800" b="0" lang="ja-JP">
-                <a:solidFill>
-                  <a:srgbClr val="626669"/>
-                </a:solidFill>
-                <a:latin typeface="Noto Sans"/>
-                <a:ea typeface="Noto Sans CJK JP"/>
-                <a:cs typeface="Noto Sans"/>
-              </a:rPr>
-              <a:t/>
-            </a:r>
-            <a:r>
-              <a:rPr sz="800" lang="ja-JP">
-                <a:solidFill>
-                  <a:srgbClr val="626669"/>
-                </a:solidFill>
-                <a:latin typeface="Noto Sans"/>
-                <a:ea typeface="Noto Sans CJK JP"/>
-                <a:cs typeface="Noto Sans"/>
-                <a:hlinkClick r:id="rId2"/>
-              </a:rPr>
-              <a:t>https://arxiv.org/abs/1908.03195</a:t>
-            </a:r>
-          </a:p>
-        </p:txBody>
-      </p:sp>
-    </p:spTree>
-  </p:cSld>
-  <p:clrMapOvr>
-    <a:masterClrMapping/>
-  </p:clrMapOvr>
-</p:sld>
-</file>
-
 <file path=ppt/slides/slide48.xml><?xml version="1.0" encoding="utf-8"?>
 <p:sld xmlns:a="http://schemas.openxmlformats.org/drawingml/2006/main" xmlns:p="http://schemas.openxmlformats.org/presentationml/2006/main" xmlns:r="http://schemas.openxmlformats.org/officeDocument/2006/relationships">
   <p:cSld>
@@ -30750,41 +30280,6 @@
                 <a:cs typeface="Noto Sans"/>
               </a:rPr>
               <a:t>出現頻度の低いカテゴリを多く含み、頻出・少数カテゴリ別の認識性能を評価する。</a:t>
-            </a:r>
-          </a:p>
-          <a:p>
-            <a:pPr algn="l" lvl="0" marL="457200" indent="-355600">
-              <a:lnSpc>
-                <a:spcPct val="115000"/>
-              </a:lnSpc>
-              <a:spcBef>
-                <a:spcPts val="0"/>
-              </a:spcBef>
-              <a:spcAft>
-                <a:spcPts val="1000"/>
-              </a:spcAft>
-              <a:buSzPct val="60455"/>
-              <a:buFont typeface="Noto Sans CJK JP"/>
-              <a:buChar char="●"/>
-              <a:defRPr lang="ja-JP" sz="2200" b="0">
-                <a:solidFill>
-                  <a:srgbClr val="303437"/>
-                </a:solidFill>
-                <a:latin typeface="Noto Sans"/>
-                <a:ea typeface="Noto Sans CJK JP"/>
-                <a:cs typeface="Noto Sans"/>
-              </a:defRPr>
-            </a:pPr>
-            <a:r>
-              <a:rPr sz="2200" b="0" lang="ja-JP">
-                <a:solidFill>
-                  <a:srgbClr val="303437"/>
-                </a:solidFill>
-                <a:latin typeface="Noto Sans"/>
-                <a:ea typeface="Noto Sans CJK JP"/>
-                <a:cs typeface="Noto Sans"/>
-              </a:rPr>
-              <a:t>COCOと画像を共有しても、カテゴリ・注釈・評価方法が異なり、得点を直接比較できない。</a:t>
             </a:r>
           </a:p>
         </p:txBody>
@@ -31825,7 +31320,7 @@
                 <a:ea typeface="Noto Sans CJK JP"/>
                 <a:cs typeface="Noto Sans"/>
               </a:rPr>
-              <a:t>公式ページの圧縮配布サイズ。展開後の容量ではない。画像の利用条件はFlickr側のライセンスも確認する [1]。</a:t>
+              <a:t>画像の利用条件はFlickr側のライセンスも確認する [1]。</a:t>
             </a:r>
           </a:p>
         </p:txBody>
@@ -32592,7 +32087,7 @@
                 <a:ea typeface="Noto Sans CJK JP"/>
                 <a:cs typeface="Noto Sans"/>
               </a:rPr>
-              <a:t>annToMaskは多角形やRLEを画像と同じ縦横の二値マスクへ変換する。表示用の縮小画像の寸法と混同しない。</a:t>
+              <a:t>annToMaskは多角形やRLEを画像と同じ縦横の二値マスクへ変換する。</a:t>
             </a:r>
           </a:p>
         </p:txBody>
@@ -32911,7 +32406,7 @@
                 <a:ea typeface="Noto Sans CJK JP"/>
                 <a:cs typeface="Noto Sans"/>
               </a:rPr>
-              <a:t>検出・個体分割のAPとPanopticのPQは異なる指標である。範囲・版・評価集合をそろえて結果を読む。</a:t>
+              <a:t>検出・個体分割はAP、Panoptic分割はPQで評価する。</a:t>
             </a:r>
           </a:p>
         </p:txBody>
@@ -34897,39 +34392,7 @@
             <a:spAutoFit/>
           </a:bodyPr>
           <a:lstStyle/>
-          <a:p>
-            <a:pPr algn="l">
-              <a:lnSpc>
-                <a:spcPct val="115000"/>
-              </a:lnSpc>
-              <a:spcBef>
-                <a:spcPts val="0"/>
-              </a:spcBef>
-              <a:spcAft>
-                <a:spcPts val="0"/>
-              </a:spcAft>
-              <a:buNone/>
-              <a:defRPr lang="ja-JP" sz="1900" b="0">
-                <a:solidFill>
-                  <a:srgbClr val="303437"/>
-                </a:solidFill>
-                <a:latin typeface="Noto Sans"/>
-                <a:ea typeface="Noto Sans CJK JP"/>
-                <a:cs typeface="Noto Sans"/>
-              </a:defRPr>
-            </a:pPr>
-            <a:r>
-              <a:rPr lang="ja-JP" sz="1900" b="0">
-                <a:solidFill>
-                  <a:srgbClr val="303437"/>
-                </a:solidFill>
-                <a:latin typeface="Noto Sans"/>
-                <a:ea typeface="Noto Sans CJK JP"/>
-                <a:cs typeface="Noto Sans"/>
-              </a:rPr>
-              <a:t>意味的領域分割では、同じカテゴリに属する複数の人を個体として区別する必要がない。</a:t>
-            </a:r>
-          </a:p>
+          <a:p/>
         </p:txBody>
       </p:sp>
       <p:sp>
@@ -36667,7 +36130,7 @@
                 <a:ea typeface="Noto Sans CJK JP"/>
                 <a:cs typeface="Noto Sans"/>
               </a:rPr>
-              <a:t>全体の配布画像は約330K枚だが、以下の集計はCOCO128-segの128画像に限定する。</a:t>
+              <a:t>分析対象はCOCO128-segの128画像である [1]。</a:t>
             </a:r>
           </a:p>
           <a:p>
@@ -36693,31 +36156,6 @@
                 <a:cs typeface="Noto Sans"/>
               </a:rPr>
               <a:t>公開変換された領域注釈を画像ごとに数え、注釈ファイルがない2画像は0領域として含める。</a:t>
-            </a:r>
-          </a:p>
-          <a:p>
-            <a:pPr algn="ctr" marL="0" indent="0">
-              <a:lnSpc>
-                <a:spcPct val="100000"/>
-              </a:lnSpc>
-              <a:spcBef>
-                <a:spcPts val="0"/>
-              </a:spcBef>
-              <a:spcAft>
-                <a:spcPts val="1200"/>
-              </a:spcAft>
-              <a:buNone/>
-            </a:pPr>
-            <a:r>
-              <a:rPr sz="2000" b="0" lang="ja-JP">
-                <a:solidFill>
-                  <a:srgbClr val="303437"/>
-                </a:solidFill>
-                <a:latin typeface="Noto Sans"/>
-                <a:ea typeface="Noto Sans CJK JP"/>
-                <a:cs typeface="Noto Sans"/>
-              </a:rPr>
-              <a:t>これは例示用の小さな部分集合。カテゴリ頻度や領域数の分布をCOCO全体へ一般化しない [1]。</a:t>
             </a:r>
           </a:p>
         </p:txBody>
@@ -43255,7 +42693,7 @@
                 <a:ea typeface="Noto Sans CJK JP"/>
                 <a:cs typeface="Noto Sans"/>
               </a:rPr>
-              <a:t>公式APIはBSD形式の利用条件を持つ。画像・注釈・コードで利用条件が異なる [1]。</a:t>
+              <a:t>公式APIはBSD形式の利用条件を持つ [1]。</a:t>
             </a:r>
           </a:p>
         </p:txBody>

</xml_diff>

<commit_message>
Proofread coco with Japanese proofreading skill
</commit_message>
<xml_diff>
--- a/slides/datasets-in-10-minutes-coco.pptx
+++ b/slides/datasets-in-10-minutes-coco.pptx
@@ -10043,7 +10043,7 @@
                 <a:ea typeface="Noto Sans CJK JP"/>
                 <a:cs typeface="Noto Sans"/>
               </a:rPr>
-              <a:t>画像分類大会ILSVRC 2012では、1,000クラスの画像分類が広く使われた。</a:t>
+              <a:t>画像分類大会ILSVRC 2012では、1,000クラスの画像分類タスクが広く使われた。</a:t>
             </a:r>
           </a:p>
           <a:p>
@@ -10975,7 +10975,7 @@
                 <a:ea typeface="Noto Sans CJK JP"/>
                 <a:cs typeface="Noto Sans"/>
               </a:rPr>
-              <a:t>先行データとCOCOでは正解の単位が異なる</a:t>
+              <a:t>先行データとCOCOの正解単位とカテゴリ数</a:t>
             </a:r>
           </a:p>
         </p:txBody>
@@ -11325,7 +11325,7 @@
                           <a:ea typeface="Noto Sans CJK JP"/>
                           <a:cs typeface="Noto Sans"/>
                         </a:rPr>
-                        <a:t>カテゴリ</a:t>
+                        <a:t>カテゴリ数</a:t>
                       </a:r>
                     </a:p>
                   </a:txBody>
@@ -12437,7 +12437,7 @@
                 <a:ea typeface="Noto Sans CJK JP"/>
                 <a:cs typeface="Noto Sans"/>
               </a:rPr>
-              <a:t>カテゴリの存在確認、個体の特定、輪郭の作成を分け、各段階で注釈品質を確認した。</a:t>
+              <a:t>カテゴリの存在確認、個体の特定、輪郭の作成に段階を分け、各段階で注釈品質を確認した。</a:t>
             </a:r>
           </a:p>
           <a:p>
@@ -12472,7 +12472,7 @@
                 <a:ea typeface="Noto Sans CJK JP"/>
                 <a:cs typeface="Noto Sans"/>
               </a:rPr>
-              <a:t>現在の物体注釈は、カテゴリ・矩形・領域マスクなどを同じレコードにまとめる。</a:t>
+              <a:t>COCOの物体注釈は、カテゴリ・矩形・領域マスクなどを同じレコードにまとめる。</a:t>
             </a:r>
           </a:p>
         </p:txBody>
@@ -12876,7 +12876,7 @@
                 <a:ea typeface="Noto Sans CJK JP"/>
                 <a:cs typeface="Noto Sans"/>
               </a:rPr>
-              <a:t>個体の特定では、何人・何本の傘があり、どの位置にあるかを分ける。</a:t>
+              <a:t>個体の特定では、人や傘の数と、それぞれの位置を区別する。</a:t>
             </a:r>
           </a:p>
           <a:p>
@@ -19923,7 +19923,7 @@
                 <a:ea typeface="Noto Sans CJK JP"/>
                 <a:cs typeface="Noto Sans"/>
               </a:rPr>
-              <a:t>COCO 2017の画像分割</a:t>
+              <a:t>COCO 2017のデータ分割</a:t>
             </a:r>
           </a:p>
         </p:txBody>
@@ -20038,7 +20038,7 @@
                           <a:ea typeface="Noto Sans CJK JP"/>
                           <a:cs typeface="Noto Sans"/>
                         </a:rPr>
-                        <a:t>分割</a:t>
+                        <a:t>データ分割</a:t>
                       </a:r>
                     </a:p>
                   </a:txBody>
@@ -21584,7 +21584,7 @@
                 <a:ea typeface="Noto Sans CJK JP"/>
                 <a:cs typeface="Noto Sans"/>
               </a:rPr>
-              <a:t>実画像の傘で面積の大きさを比べる</a:t>
+              <a:t>実画像の傘で面積を比べる</a:t>
             </a:r>
           </a:p>
         </p:txBody>
@@ -23596,7 +23596,7 @@
         </p:nvSpPr>
         <p:spPr>
           <a:xfrm>
-            <a:off x="2880360" y="3291840"/>
+            <a:off x="2880360" y="3456940"/>
             <a:ext cx="1005840" cy="365760"/>
           </a:xfrm>
           <a:prstGeom prst="rect">
@@ -23784,7 +23784,7 @@
                 <a:ea typeface="Noto Sans CJK JP"/>
                 <a:cs typeface="Noto Sans"/>
               </a:rPr>
-              <a:t>IoU 0.50で一致とはならない。</a:t>
+              <a:t>IoU 0.50では一致と判定されない。</a:t>
             </a:r>
           </a:p>
           <a:p>
@@ -24023,7 +24023,7 @@
                 <a:ea typeface="Noto Sans CJK JP"/>
                 <a:cs typeface="Noto Sans"/>
               </a:rPr>
-              <a:t>正しいカテゴリで正解領域へ一致した予測を真陽性TPとする。</a:t>
+              <a:t>正しいカテゴリで正解領域と一致した予測を真陽性TPとする。</a:t>
             </a:r>
           </a:p>
           <a:p>
@@ -24058,7 +24058,7 @@
                 <a:ea typeface="Noto Sans CJK JP"/>
                 <a:cs typeface="Noto Sans"/>
               </a:rPr>
-              <a:t>正解へ一致しない予測や、同じ物体への重複した予測を偽陽性FPとする。</a:t>
+              <a:t>正解と一致しない予測や、同じ物体への重複した予測を偽陽性FPとする。</a:t>
             </a:r>
           </a:p>
           <a:p>
@@ -25982,7 +25982,7 @@
                 <a:ea typeface="Noto Sans CJK JP"/>
                 <a:cs typeface="Noto Sans"/>
               </a:rPr>
-              <a:t>数えにくい集団にはcrowd注釈がある</a:t>
+              <a:t>crowd注釈と検出誤差の扱い</a:t>
             </a:r>
           </a:p>
         </p:txBody>
@@ -35813,7 +35813,7 @@
                 <a:ea typeface="Noto Sans CJK JP"/>
                 <a:cs typeface="Noto Sans"/>
               </a:rPr>
-              <a:t>各カテゴリ・各IoU閾値で、信頼度順の予測から適合率・再現率を作る。</a:t>
+              <a:t>各カテゴリ・各IoU閾値で、信頼度順の予測から適合率・再現率を算出する。</a:t>
             </a:r>
           </a:p>
           <a:p>
@@ -36155,7 +36155,7 @@
                 <a:ea typeface="Noto Sans CJK JP"/>
                 <a:cs typeface="Noto Sans"/>
               </a:rPr>
-              <a:t>公開変換された領域注釈を画像ごとに数え、注釈ファイルがない2画像は0領域として含める。</a:t>
+              <a:t>変換して公開された領域注釈を画像ごとに数え、注釈ファイルがない2画像は領域数0として含める。</a:t>
             </a:r>
           </a:p>
         </p:txBody>

</xml_diff>

<commit_message>
Use left-aligned explanatory prose in coco
</commit_message>
<xml_diff>
--- a/slides/datasets-in-10-minutes-coco.pptx
+++ b/slides/datasets-in-10-minutes-coco.pptx
@@ -36039,7 +36039,7 @@
         </p:nvSpPr>
         <p:spPr>
           <a:xfrm>
-            <a:off x="468172" y="1306154"/>
+            <a:off x="468172" y="650240"/>
             <a:ext cx="8206740" cy="594360"/>
           </a:xfrm>
         </p:spPr>
@@ -36047,7 +36047,7 @@
           <a:bodyPr wrap="square" anchor="t" lIns="0" rIns="0" tIns="0" bIns="0"/>
           <a:lstStyle/>
           <a:p>
-            <a:pPr algn="ctr">
+            <a:pPr algn="l">
               <a:lnSpc>
                 <a:spcPct val="100000"/>
               </a:lnSpc>
@@ -36093,15 +36093,15 @@
         </p:nvSpPr>
         <p:spPr>
           <a:xfrm>
-            <a:off x="594360" y="2220554"/>
-            <a:ext cx="7955279" cy="1737360"/>
+            <a:off x="594360" y="1508760"/>
+            <a:ext cx="7955279" cy="2794000"/>
           </a:xfrm>
         </p:spPr>
         <p:txBody>
           <a:bodyPr wrap="square" anchor="t" tIns="0" bIns="0" lIns="0" rIns="0"/>
           <a:lstStyle/>
           <a:p>
-            <a:pPr algn="ctr" lvl="0" marL="0" indent="0">
+            <a:pPr algn="l" lvl="0" marL="0" indent="0">
               <a:lnSpc>
                 <a:spcPct val="100000"/>
               </a:lnSpc>
@@ -36130,11 +36130,11 @@
                 <a:ea typeface="Noto Sans CJK JP"/>
                 <a:cs typeface="Noto Sans"/>
               </a:rPr>
-              <a:t>分析対象はCOCO128-segの128画像である [1]。</a:t>
-            </a:r>
-          </a:p>
-          <a:p>
-            <a:pPr algn="ctr" marL="0" indent="0">
+              <a:t>分析には、COCO128-segの128枚の画像を使う [1]。</a:t>
+            </a:r>
+          </a:p>
+          <a:p>
+            <a:pPr algn="l" marL="0" indent="0">
               <a:lnSpc>
                 <a:spcPct val="100000"/>
               </a:lnSpc>
@@ -36155,7 +36155,7 @@
                 <a:ea typeface="Noto Sans CJK JP"/>
                 <a:cs typeface="Noto Sans"/>
               </a:rPr>
-              <a:t>変換して公開された領域注釈を画像ごとに数え、注釈ファイルがない2画像は領域数0として含める。</a:t>
+              <a:t>変換・公開された領域注釈を画像ごとに数え、注釈ファイルがない2枚は領域数を0として集計に含める。</a:t>
             </a:r>
           </a:p>
         </p:txBody>

</xml_diff>

<commit_message>
Improve coco answer visibility and citation wording
</commit_message>
<xml_diff>
--- a/slides/datasets-in-10-minutes-coco.pptx
+++ b/slides/datasets-in-10-minutes-coco.pptx
@@ -23541,7 +23541,7 @@
         <p:spPr>
           <a:xfrm>
             <a:off x="1005840" y="1371600"/>
-            <a:ext cx="1645920" cy="365760"/>
+            <a:ext cx="1645920" cy="434902"/>
           </a:xfrm>
           <a:prstGeom prst="rect">
             <a:avLst/>
@@ -23577,7 +23577,7 @@
             <a:r>
               <a:rPr lang="ja-JP" sz="2200" b="1">
                 <a:solidFill>
-                  <a:srgbClr val="2C9100"/>
+                  <a:schemeClr val="accent1"/>
                 </a:solidFill>
                 <a:latin typeface="Noto Sans"/>
                 <a:ea typeface="Noto Sans CJK JP"/>

</xml_diff>